<commit_message>
Décorations complémentaires pour le protocole température
</commit_message>
<xml_diff>
--- a/icons/20250707-BackgroundNekton.pptx
+++ b/icons/20250707-BackgroundNekton.pptx
@@ -5,11 +5,14 @@
     <p:sldMasterId id="2147483648" r:id="rId1"/>
   </p:sldMasterIdLst>
   <p:handoutMasterIdLst>
-    <p:handoutMasterId r:id="rId4"/>
+    <p:handoutMasterId r:id="rId7"/>
   </p:handoutMasterIdLst>
   <p:sldIdLst>
-    <p:sldId id="261" r:id="rId2"/>
-    <p:sldId id="262" r:id="rId3"/>
+    <p:sldId id="263" r:id="rId2"/>
+    <p:sldId id="256" r:id="rId3"/>
+    <p:sldId id="264" r:id="rId4"/>
+    <p:sldId id="261" r:id="rId5"/>
+    <p:sldId id="262" r:id="rId6"/>
   </p:sldIdLst>
   <p:sldSz cx="9144000" cy="6858000" type="screen4x3"/>
   <p:notesSz cx="6794500" cy="9906000"/>
@@ -209,7 +212,7 @@
           <a:p>
             <a:fld id="{D7428B70-92E3-48E1-BE49-F8A05A0EC16C}" type="datetimeFigureOut">
               <a:rPr lang="fr-FR" smtClean="0"/>
-              <a:t>07/07/2025</a:t>
+              <a:t>11/05/2026</a:t>
             </a:fld>
             <a:endParaRPr lang="fr-FR"/>
           </a:p>
@@ -330,10 +333,9 @@
           <a:lstStyle/>
           <a:p>
             <a:r>
-              <a:rPr lang="fr-FR" smtClean="0"/>
+              <a:rPr lang="fr-FR"/>
               <a:t>Modifiez le style du titre</a:t>
             </a:r>
-            <a:endParaRPr lang="fr-FR"/>
           </a:p>
         </p:txBody>
       </p:sp>
@@ -449,10 +451,9 @@
           </a:lstStyle>
           <a:p>
             <a:r>
-              <a:rPr lang="fr-FR" smtClean="0"/>
+              <a:rPr lang="fr-FR"/>
               <a:t>Modifiez le style des sous-titres du masque</a:t>
             </a:r>
-            <a:endParaRPr lang="fr-FR"/>
           </a:p>
         </p:txBody>
       </p:sp>
@@ -473,7 +474,7 @@
           <a:p>
             <a:fld id="{D7E1F5DE-F893-487E-8A46-2A5279405891}" type="datetimeFigureOut">
               <a:rPr lang="fr-FR" smtClean="0"/>
-              <a:t>07/07/2025</a:t>
+              <a:t>11/05/2026</a:t>
             </a:fld>
             <a:endParaRPr lang="fr-FR"/>
           </a:p>
@@ -567,10 +568,9 @@
           <a:lstStyle/>
           <a:p>
             <a:r>
-              <a:rPr lang="fr-FR" smtClean="0"/>
+              <a:rPr lang="fr-FR"/>
               <a:t>Modifiez le style du titre</a:t>
             </a:r>
-            <a:endParaRPr lang="fr-FR"/>
           </a:p>
         </p:txBody>
       </p:sp>
@@ -591,38 +591,37 @@
           <a:p>
             <a:pPr lvl="0"/>
             <a:r>
-              <a:rPr lang="fr-FR" smtClean="0"/>
+              <a:rPr lang="fr-FR"/>
               <a:t>Modifiez les styles du texte du masque</a:t>
             </a:r>
           </a:p>
           <a:p>
             <a:pPr lvl="1"/>
             <a:r>
-              <a:rPr lang="fr-FR" smtClean="0"/>
+              <a:rPr lang="fr-FR"/>
               <a:t>Deuxième niveau</a:t>
             </a:r>
           </a:p>
           <a:p>
             <a:pPr lvl="2"/>
             <a:r>
-              <a:rPr lang="fr-FR" smtClean="0"/>
+              <a:rPr lang="fr-FR"/>
               <a:t>Troisième niveau</a:t>
             </a:r>
           </a:p>
           <a:p>
             <a:pPr lvl="3"/>
             <a:r>
-              <a:rPr lang="fr-FR" smtClean="0"/>
+              <a:rPr lang="fr-FR"/>
               <a:t>Quatrième niveau</a:t>
             </a:r>
           </a:p>
           <a:p>
             <a:pPr lvl="4"/>
             <a:r>
-              <a:rPr lang="fr-FR" smtClean="0"/>
+              <a:rPr lang="fr-FR"/>
               <a:t>Cinquième niveau</a:t>
             </a:r>
-            <a:endParaRPr lang="fr-FR"/>
           </a:p>
         </p:txBody>
       </p:sp>
@@ -643,7 +642,7 @@
           <a:p>
             <a:fld id="{D7E1F5DE-F893-487E-8A46-2A5279405891}" type="datetimeFigureOut">
               <a:rPr lang="fr-FR" smtClean="0"/>
-              <a:t>07/07/2025</a:t>
+              <a:t>11/05/2026</a:t>
             </a:fld>
             <a:endParaRPr lang="fr-FR"/>
           </a:p>
@@ -742,10 +741,9 @@
           <a:lstStyle/>
           <a:p>
             <a:r>
-              <a:rPr lang="fr-FR" smtClean="0"/>
+              <a:rPr lang="fr-FR"/>
               <a:t>Modifiez le style du titre</a:t>
             </a:r>
-            <a:endParaRPr lang="fr-FR"/>
           </a:p>
         </p:txBody>
       </p:sp>
@@ -771,38 +769,37 @@
           <a:p>
             <a:pPr lvl="0"/>
             <a:r>
-              <a:rPr lang="fr-FR" smtClean="0"/>
+              <a:rPr lang="fr-FR"/>
               <a:t>Modifiez les styles du texte du masque</a:t>
             </a:r>
           </a:p>
           <a:p>
             <a:pPr lvl="1"/>
             <a:r>
-              <a:rPr lang="fr-FR" smtClean="0"/>
+              <a:rPr lang="fr-FR"/>
               <a:t>Deuxième niveau</a:t>
             </a:r>
           </a:p>
           <a:p>
             <a:pPr lvl="2"/>
             <a:r>
-              <a:rPr lang="fr-FR" smtClean="0"/>
+              <a:rPr lang="fr-FR"/>
               <a:t>Troisième niveau</a:t>
             </a:r>
           </a:p>
           <a:p>
             <a:pPr lvl="3"/>
             <a:r>
-              <a:rPr lang="fr-FR" smtClean="0"/>
+              <a:rPr lang="fr-FR"/>
               <a:t>Quatrième niveau</a:t>
             </a:r>
           </a:p>
           <a:p>
             <a:pPr lvl="4"/>
             <a:r>
-              <a:rPr lang="fr-FR" smtClean="0"/>
+              <a:rPr lang="fr-FR"/>
               <a:t>Cinquième niveau</a:t>
             </a:r>
-            <a:endParaRPr lang="fr-FR"/>
           </a:p>
         </p:txBody>
       </p:sp>
@@ -823,7 +820,7 @@
           <a:p>
             <a:fld id="{D7E1F5DE-F893-487E-8A46-2A5279405891}" type="datetimeFigureOut">
               <a:rPr lang="fr-FR" smtClean="0"/>
-              <a:t>07/07/2025</a:t>
+              <a:t>11/05/2026</a:t>
             </a:fld>
             <a:endParaRPr lang="fr-FR"/>
           </a:p>
@@ -917,10 +914,9 @@
           <a:lstStyle/>
           <a:p>
             <a:r>
-              <a:rPr lang="fr-FR" smtClean="0"/>
+              <a:rPr lang="fr-FR"/>
               <a:t>Modifiez le style du titre</a:t>
             </a:r>
-            <a:endParaRPr lang="fr-FR"/>
           </a:p>
         </p:txBody>
       </p:sp>
@@ -941,38 +937,37 @@
           <a:p>
             <a:pPr lvl="0"/>
             <a:r>
-              <a:rPr lang="fr-FR" smtClean="0"/>
+              <a:rPr lang="fr-FR"/>
               <a:t>Modifiez les styles du texte du masque</a:t>
             </a:r>
           </a:p>
           <a:p>
             <a:pPr lvl="1"/>
             <a:r>
-              <a:rPr lang="fr-FR" smtClean="0"/>
+              <a:rPr lang="fr-FR"/>
               <a:t>Deuxième niveau</a:t>
             </a:r>
           </a:p>
           <a:p>
             <a:pPr lvl="2"/>
             <a:r>
-              <a:rPr lang="fr-FR" smtClean="0"/>
+              <a:rPr lang="fr-FR"/>
               <a:t>Troisième niveau</a:t>
             </a:r>
           </a:p>
           <a:p>
             <a:pPr lvl="3"/>
             <a:r>
-              <a:rPr lang="fr-FR" smtClean="0"/>
+              <a:rPr lang="fr-FR"/>
               <a:t>Quatrième niveau</a:t>
             </a:r>
           </a:p>
           <a:p>
             <a:pPr lvl="4"/>
             <a:r>
-              <a:rPr lang="fr-FR" smtClean="0"/>
+              <a:rPr lang="fr-FR"/>
               <a:t>Cinquième niveau</a:t>
             </a:r>
-            <a:endParaRPr lang="fr-FR"/>
           </a:p>
         </p:txBody>
       </p:sp>
@@ -993,7 +988,7 @@
           <a:p>
             <a:fld id="{D7E1F5DE-F893-487E-8A46-2A5279405891}" type="datetimeFigureOut">
               <a:rPr lang="fr-FR" smtClean="0"/>
-              <a:t>07/07/2025</a:t>
+              <a:t>11/05/2026</a:t>
             </a:fld>
             <a:endParaRPr lang="fr-FR"/>
           </a:p>
@@ -1096,10 +1091,9 @@
           </a:lstStyle>
           <a:p>
             <a:r>
-              <a:rPr lang="fr-FR" smtClean="0"/>
+              <a:rPr lang="fr-FR"/>
               <a:t>Modifiez le style du titre</a:t>
             </a:r>
-            <a:endParaRPr lang="fr-FR"/>
           </a:p>
         </p:txBody>
       </p:sp>
@@ -1216,7 +1210,7 @@
           <a:p>
             <a:pPr lvl="0"/>
             <a:r>
-              <a:rPr lang="fr-FR" smtClean="0"/>
+              <a:rPr lang="fr-FR"/>
               <a:t>Modifiez les styles du texte du masque</a:t>
             </a:r>
           </a:p>
@@ -1239,7 +1233,7 @@
           <a:p>
             <a:fld id="{D7E1F5DE-F893-487E-8A46-2A5279405891}" type="datetimeFigureOut">
               <a:rPr lang="fr-FR" smtClean="0"/>
-              <a:t>07/07/2025</a:t>
+              <a:t>11/05/2026</a:t>
             </a:fld>
             <a:endParaRPr lang="fr-FR"/>
           </a:p>
@@ -1333,10 +1327,9 @@
           <a:lstStyle/>
           <a:p>
             <a:r>
-              <a:rPr lang="fr-FR" smtClean="0"/>
+              <a:rPr lang="fr-FR"/>
               <a:t>Modifiez le style du titre</a:t>
             </a:r>
-            <a:endParaRPr lang="fr-FR"/>
           </a:p>
         </p:txBody>
       </p:sp>
@@ -1390,38 +1383,37 @@
           <a:p>
             <a:pPr lvl="0"/>
             <a:r>
-              <a:rPr lang="fr-FR" smtClean="0"/>
+              <a:rPr lang="fr-FR"/>
               <a:t>Modifiez les styles du texte du masque</a:t>
             </a:r>
           </a:p>
           <a:p>
             <a:pPr lvl="1"/>
             <a:r>
-              <a:rPr lang="fr-FR" smtClean="0"/>
+              <a:rPr lang="fr-FR"/>
               <a:t>Deuxième niveau</a:t>
             </a:r>
           </a:p>
           <a:p>
             <a:pPr lvl="2"/>
             <a:r>
-              <a:rPr lang="fr-FR" smtClean="0"/>
+              <a:rPr lang="fr-FR"/>
               <a:t>Troisième niveau</a:t>
             </a:r>
           </a:p>
           <a:p>
             <a:pPr lvl="3"/>
             <a:r>
-              <a:rPr lang="fr-FR" smtClean="0"/>
+              <a:rPr lang="fr-FR"/>
               <a:t>Quatrième niveau</a:t>
             </a:r>
           </a:p>
           <a:p>
             <a:pPr lvl="4"/>
             <a:r>
-              <a:rPr lang="fr-FR" smtClean="0"/>
+              <a:rPr lang="fr-FR"/>
               <a:t>Cinquième niveau</a:t>
             </a:r>
-            <a:endParaRPr lang="fr-FR"/>
           </a:p>
         </p:txBody>
       </p:sp>
@@ -1475,38 +1467,37 @@
           <a:p>
             <a:pPr lvl="0"/>
             <a:r>
-              <a:rPr lang="fr-FR" smtClean="0"/>
+              <a:rPr lang="fr-FR"/>
               <a:t>Modifiez les styles du texte du masque</a:t>
             </a:r>
           </a:p>
           <a:p>
             <a:pPr lvl="1"/>
             <a:r>
-              <a:rPr lang="fr-FR" smtClean="0"/>
+              <a:rPr lang="fr-FR"/>
               <a:t>Deuxième niveau</a:t>
             </a:r>
           </a:p>
           <a:p>
             <a:pPr lvl="2"/>
             <a:r>
-              <a:rPr lang="fr-FR" smtClean="0"/>
+              <a:rPr lang="fr-FR"/>
               <a:t>Troisième niveau</a:t>
             </a:r>
           </a:p>
           <a:p>
             <a:pPr lvl="3"/>
             <a:r>
-              <a:rPr lang="fr-FR" smtClean="0"/>
+              <a:rPr lang="fr-FR"/>
               <a:t>Quatrième niveau</a:t>
             </a:r>
           </a:p>
           <a:p>
             <a:pPr lvl="4"/>
             <a:r>
-              <a:rPr lang="fr-FR" smtClean="0"/>
+              <a:rPr lang="fr-FR"/>
               <a:t>Cinquième niveau</a:t>
             </a:r>
-            <a:endParaRPr lang="fr-FR"/>
           </a:p>
         </p:txBody>
       </p:sp>
@@ -1527,7 +1518,7 @@
           <a:p>
             <a:fld id="{D7E1F5DE-F893-487E-8A46-2A5279405891}" type="datetimeFigureOut">
               <a:rPr lang="fr-FR" smtClean="0"/>
-              <a:t>07/07/2025</a:t>
+              <a:t>11/05/2026</a:t>
             </a:fld>
             <a:endParaRPr lang="fr-FR"/>
           </a:p>
@@ -1625,10 +1616,9 @@
           </a:lstStyle>
           <a:p>
             <a:r>
-              <a:rPr lang="fr-FR" smtClean="0"/>
+              <a:rPr lang="fr-FR"/>
               <a:t>Modifiez le style du titre</a:t>
             </a:r>
-            <a:endParaRPr lang="fr-FR"/>
           </a:p>
         </p:txBody>
       </p:sp>
@@ -1691,7 +1681,7 @@
           <a:p>
             <a:pPr lvl="0"/>
             <a:r>
-              <a:rPr lang="fr-FR" smtClean="0"/>
+              <a:rPr lang="fr-FR"/>
               <a:t>Modifiez les styles du texte du masque</a:t>
             </a:r>
           </a:p>
@@ -1747,38 +1737,37 @@
           <a:p>
             <a:pPr lvl="0"/>
             <a:r>
-              <a:rPr lang="fr-FR" smtClean="0"/>
+              <a:rPr lang="fr-FR"/>
               <a:t>Modifiez les styles du texte du masque</a:t>
             </a:r>
           </a:p>
           <a:p>
             <a:pPr lvl="1"/>
             <a:r>
-              <a:rPr lang="fr-FR" smtClean="0"/>
+              <a:rPr lang="fr-FR"/>
               <a:t>Deuxième niveau</a:t>
             </a:r>
           </a:p>
           <a:p>
             <a:pPr lvl="2"/>
             <a:r>
-              <a:rPr lang="fr-FR" smtClean="0"/>
+              <a:rPr lang="fr-FR"/>
               <a:t>Troisième niveau</a:t>
             </a:r>
           </a:p>
           <a:p>
             <a:pPr lvl="3"/>
             <a:r>
-              <a:rPr lang="fr-FR" smtClean="0"/>
+              <a:rPr lang="fr-FR"/>
               <a:t>Quatrième niveau</a:t>
             </a:r>
           </a:p>
           <a:p>
             <a:pPr lvl="4"/>
             <a:r>
-              <a:rPr lang="fr-FR" smtClean="0"/>
+              <a:rPr lang="fr-FR"/>
               <a:t>Cinquième niveau</a:t>
             </a:r>
-            <a:endParaRPr lang="fr-FR"/>
           </a:p>
         </p:txBody>
       </p:sp>
@@ -1841,7 +1830,7 @@
           <a:p>
             <a:pPr lvl="0"/>
             <a:r>
-              <a:rPr lang="fr-FR" smtClean="0"/>
+              <a:rPr lang="fr-FR"/>
               <a:t>Modifiez les styles du texte du masque</a:t>
             </a:r>
           </a:p>
@@ -1897,38 +1886,37 @@
           <a:p>
             <a:pPr lvl="0"/>
             <a:r>
-              <a:rPr lang="fr-FR" smtClean="0"/>
+              <a:rPr lang="fr-FR"/>
               <a:t>Modifiez les styles du texte du masque</a:t>
             </a:r>
           </a:p>
           <a:p>
             <a:pPr lvl="1"/>
             <a:r>
-              <a:rPr lang="fr-FR" smtClean="0"/>
+              <a:rPr lang="fr-FR"/>
               <a:t>Deuxième niveau</a:t>
             </a:r>
           </a:p>
           <a:p>
             <a:pPr lvl="2"/>
             <a:r>
-              <a:rPr lang="fr-FR" smtClean="0"/>
+              <a:rPr lang="fr-FR"/>
               <a:t>Troisième niveau</a:t>
             </a:r>
           </a:p>
           <a:p>
             <a:pPr lvl="3"/>
             <a:r>
-              <a:rPr lang="fr-FR" smtClean="0"/>
+              <a:rPr lang="fr-FR"/>
               <a:t>Quatrième niveau</a:t>
             </a:r>
           </a:p>
           <a:p>
             <a:pPr lvl="4"/>
             <a:r>
-              <a:rPr lang="fr-FR" smtClean="0"/>
+              <a:rPr lang="fr-FR"/>
               <a:t>Cinquième niveau</a:t>
             </a:r>
-            <a:endParaRPr lang="fr-FR"/>
           </a:p>
         </p:txBody>
       </p:sp>
@@ -1949,7 +1937,7 @@
           <a:p>
             <a:fld id="{D7E1F5DE-F893-487E-8A46-2A5279405891}" type="datetimeFigureOut">
               <a:rPr lang="fr-FR" smtClean="0"/>
-              <a:t>07/07/2025</a:t>
+              <a:t>11/05/2026</a:t>
             </a:fld>
             <a:endParaRPr lang="fr-FR"/>
           </a:p>
@@ -2043,10 +2031,9 @@
           <a:lstStyle/>
           <a:p>
             <a:r>
-              <a:rPr lang="fr-FR" smtClean="0"/>
+              <a:rPr lang="fr-FR"/>
               <a:t>Modifiez le style du titre</a:t>
             </a:r>
-            <a:endParaRPr lang="fr-FR"/>
           </a:p>
         </p:txBody>
       </p:sp>
@@ -2067,7 +2054,7 @@
           <a:p>
             <a:fld id="{D7E1F5DE-F893-487E-8A46-2A5279405891}" type="datetimeFigureOut">
               <a:rPr lang="fr-FR" smtClean="0"/>
-              <a:t>07/07/2025</a:t>
+              <a:t>11/05/2026</a:t>
             </a:fld>
             <a:endParaRPr lang="fr-FR"/>
           </a:p>
@@ -2162,7 +2149,7 @@
           <a:p>
             <a:fld id="{D7E1F5DE-F893-487E-8A46-2A5279405891}" type="datetimeFigureOut">
               <a:rPr lang="fr-FR" smtClean="0"/>
-              <a:t>07/07/2025</a:t>
+              <a:t>11/05/2026</a:t>
             </a:fld>
             <a:endParaRPr lang="fr-FR"/>
           </a:p>
@@ -2265,10 +2252,9 @@
           </a:lstStyle>
           <a:p>
             <a:r>
-              <a:rPr lang="fr-FR" smtClean="0"/>
+              <a:rPr lang="fr-FR"/>
               <a:t>Modifiez le style du titre</a:t>
             </a:r>
-            <a:endParaRPr lang="fr-FR"/>
           </a:p>
         </p:txBody>
       </p:sp>
@@ -2322,38 +2308,37 @@
           <a:p>
             <a:pPr lvl="0"/>
             <a:r>
-              <a:rPr lang="fr-FR" smtClean="0"/>
+              <a:rPr lang="fr-FR"/>
               <a:t>Modifiez les styles du texte du masque</a:t>
             </a:r>
           </a:p>
           <a:p>
             <a:pPr lvl="1"/>
             <a:r>
-              <a:rPr lang="fr-FR" smtClean="0"/>
+              <a:rPr lang="fr-FR"/>
               <a:t>Deuxième niveau</a:t>
             </a:r>
           </a:p>
           <a:p>
             <a:pPr lvl="2"/>
             <a:r>
-              <a:rPr lang="fr-FR" smtClean="0"/>
+              <a:rPr lang="fr-FR"/>
               <a:t>Troisième niveau</a:t>
             </a:r>
           </a:p>
           <a:p>
             <a:pPr lvl="3"/>
             <a:r>
-              <a:rPr lang="fr-FR" smtClean="0"/>
+              <a:rPr lang="fr-FR"/>
               <a:t>Quatrième niveau</a:t>
             </a:r>
           </a:p>
           <a:p>
             <a:pPr lvl="4"/>
             <a:r>
-              <a:rPr lang="fr-FR" smtClean="0"/>
+              <a:rPr lang="fr-FR"/>
               <a:t>Cinquième niveau</a:t>
             </a:r>
-            <a:endParaRPr lang="fr-FR"/>
           </a:p>
         </p:txBody>
       </p:sp>
@@ -2416,7 +2401,7 @@
           <a:p>
             <a:pPr lvl="0"/>
             <a:r>
-              <a:rPr lang="fr-FR" smtClean="0"/>
+              <a:rPr lang="fr-FR"/>
               <a:t>Modifiez les styles du texte du masque</a:t>
             </a:r>
           </a:p>
@@ -2439,7 +2424,7 @@
           <a:p>
             <a:fld id="{D7E1F5DE-F893-487E-8A46-2A5279405891}" type="datetimeFigureOut">
               <a:rPr lang="fr-FR" smtClean="0"/>
-              <a:t>07/07/2025</a:t>
+              <a:t>11/05/2026</a:t>
             </a:fld>
             <a:endParaRPr lang="fr-FR"/>
           </a:p>
@@ -2542,10 +2527,9 @@
           </a:lstStyle>
           <a:p>
             <a:r>
-              <a:rPr lang="fr-FR" smtClean="0"/>
+              <a:rPr lang="fr-FR"/>
               <a:t>Modifiez le style du titre</a:t>
             </a:r>
-            <a:endParaRPr lang="fr-FR"/>
           </a:p>
         </p:txBody>
       </p:sp>
@@ -2669,7 +2653,7 @@
           <a:p>
             <a:pPr lvl="0"/>
             <a:r>
-              <a:rPr lang="fr-FR" smtClean="0"/>
+              <a:rPr lang="fr-FR"/>
               <a:t>Modifiez les styles du texte du masque</a:t>
             </a:r>
           </a:p>
@@ -2692,7 +2676,7 @@
           <a:p>
             <a:fld id="{D7E1F5DE-F893-487E-8A46-2A5279405891}" type="datetimeFigureOut">
               <a:rPr lang="fr-FR" smtClean="0"/>
-              <a:t>07/07/2025</a:t>
+              <a:t>11/05/2026</a:t>
             </a:fld>
             <a:endParaRPr lang="fr-FR"/>
           </a:p>
@@ -2801,10 +2785,9 @@
           <a:lstStyle/>
           <a:p>
             <a:r>
-              <a:rPr lang="fr-FR" smtClean="0"/>
+              <a:rPr lang="fr-FR"/>
               <a:t>Modifiez le style du titre</a:t>
             </a:r>
-            <a:endParaRPr lang="fr-FR"/>
           </a:p>
         </p:txBody>
       </p:sp>
@@ -2835,38 +2818,37 @@
           <a:p>
             <a:pPr lvl="0"/>
             <a:r>
-              <a:rPr lang="fr-FR" smtClean="0"/>
+              <a:rPr lang="fr-FR"/>
               <a:t>Modifiez les styles du texte du masque</a:t>
             </a:r>
           </a:p>
           <a:p>
             <a:pPr lvl="1"/>
             <a:r>
-              <a:rPr lang="fr-FR" smtClean="0"/>
+              <a:rPr lang="fr-FR"/>
               <a:t>Deuxième niveau</a:t>
             </a:r>
           </a:p>
           <a:p>
             <a:pPr lvl="2"/>
             <a:r>
-              <a:rPr lang="fr-FR" smtClean="0"/>
+              <a:rPr lang="fr-FR"/>
               <a:t>Troisième niveau</a:t>
             </a:r>
           </a:p>
           <a:p>
             <a:pPr lvl="3"/>
             <a:r>
-              <a:rPr lang="fr-FR" smtClean="0"/>
+              <a:rPr lang="fr-FR"/>
               <a:t>Quatrième niveau</a:t>
             </a:r>
           </a:p>
           <a:p>
             <a:pPr lvl="4"/>
             <a:r>
-              <a:rPr lang="fr-FR" smtClean="0"/>
+              <a:rPr lang="fr-FR"/>
               <a:t>Cinquième niveau</a:t>
             </a:r>
-            <a:endParaRPr lang="fr-FR"/>
           </a:p>
         </p:txBody>
       </p:sp>
@@ -2905,7 +2887,7 @@
           <a:p>
             <a:fld id="{D7E1F5DE-F893-487E-8A46-2A5279405891}" type="datetimeFigureOut">
               <a:rPr lang="fr-FR" smtClean="0"/>
-              <a:t>07/07/2025</a:t>
+              <a:t>11/05/2026</a:t>
             </a:fld>
             <a:endParaRPr lang="fr-FR"/>
           </a:p>
@@ -3280,6 +3262,1897 @@
           <a:chExt cx="0" cy="0"/>
         </a:xfrm>
       </p:grpSpPr>
+    </p:spTree>
+    <p:extLst>
+      <p:ext uri="{BB962C8B-B14F-4D97-AF65-F5344CB8AC3E}">
+        <p14:creationId xmlns:p14="http://schemas.microsoft.com/office/powerpoint/2010/main" val="3904154220"/>
+      </p:ext>
+    </p:extLst>
+  </p:cSld>
+  <p:clrMapOvr>
+    <a:masterClrMapping/>
+  </p:clrMapOvr>
+</p:sld>
+</file>
+
+<file path=ppt/slides/slide2.xml><?xml version="1.0" encoding="utf-8"?>
+<p:sld xmlns:a="http://schemas.openxmlformats.org/drawingml/2006/main" xmlns:r="http://schemas.openxmlformats.org/officeDocument/2006/relationships" xmlns:p="http://schemas.openxmlformats.org/presentationml/2006/main">
+  <p:cSld>
+    <p:spTree>
+      <p:nvGrpSpPr>
+        <p:cNvPr id="1" name=""/>
+        <p:cNvGrpSpPr/>
+        <p:nvPr/>
+      </p:nvGrpSpPr>
+      <p:grpSpPr>
+        <a:xfrm>
+          <a:off x="0" y="0"/>
+          <a:ext cx="0" cy="0"/>
+          <a:chOff x="0" y="0"/>
+          <a:chExt cx="0" cy="0"/>
+        </a:xfrm>
+      </p:grpSpPr>
+      <p:sp>
+        <p:nvSpPr>
+          <p:cNvPr id="4" name="Rectangle 3">
+            <a:extLst>
+              <a:ext uri="{FF2B5EF4-FFF2-40B4-BE49-F238E27FC236}">
+                <a16:creationId xmlns:a16="http://schemas.microsoft.com/office/drawing/2014/main" id="{97A08B69-3B1C-4AA6-935F-B8DA4B2E66E8}"/>
+              </a:ext>
+            </a:extLst>
+          </p:cNvPr>
+          <p:cNvSpPr/>
+          <p:nvPr/>
+        </p:nvSpPr>
+        <p:spPr>
+          <a:xfrm rot="16200000">
+            <a:off x="4169643" y="801337"/>
+            <a:ext cx="396000" cy="5100986"/>
+          </a:xfrm>
+          <a:prstGeom prst="rect">
+            <a:avLst/>
+          </a:prstGeom>
+          <a:gradFill>
+            <a:gsLst>
+              <a:gs pos="0">
+                <a:srgbClr val="0070C0"/>
+              </a:gs>
+              <a:gs pos="50000">
+                <a:srgbClr val="FFFF00"/>
+              </a:gs>
+              <a:gs pos="100000">
+                <a:srgbClr val="FF0000"/>
+              </a:gs>
+            </a:gsLst>
+            <a:lin ang="5400000" scaled="1"/>
+          </a:gradFill>
+        </p:spPr>
+        <p:style>
+          <a:lnRef idx="2">
+            <a:schemeClr val="accent1">
+              <a:shade val="50000"/>
+            </a:schemeClr>
+          </a:lnRef>
+          <a:fillRef idx="1">
+            <a:schemeClr val="accent1"/>
+          </a:fillRef>
+          <a:effectRef idx="0">
+            <a:schemeClr val="accent1"/>
+          </a:effectRef>
+          <a:fontRef idx="minor">
+            <a:schemeClr val="lt1"/>
+          </a:fontRef>
+        </p:style>
+        <p:txBody>
+          <a:bodyPr rot="0" spcFirstLastPara="0" vertOverflow="overflow" horzOverflow="overflow" vert="horz" wrap="square" lIns="68580" tIns="34290" rIns="68580" bIns="34290" numCol="1" spcCol="0" rtlCol="0" fromWordArt="0" anchor="ctr" anchorCtr="0" forceAA="0" compatLnSpc="1">
+            <a:prstTxWarp prst="textNoShape">
+              <a:avLst/>
+            </a:prstTxWarp>
+            <a:noAutofit/>
+          </a:bodyPr>
+          <a:lstStyle/>
+          <a:p>
+            <a:pPr algn="ctr" defTabSz="685800">
+              <a:spcAft>
+                <a:spcPts val="450"/>
+              </a:spcAft>
+            </a:pPr>
+            <a:br>
+              <a:rPr lang="fr-FR" sz="1350" dirty="0">
+                <a:solidFill>
+                  <a:prstClr val="white"/>
+                </a:solidFill>
+                <a:latin typeface="Calibri" panose="020F0502020204030204"/>
+              </a:rPr>
+            </a:br>
+            <a:endParaRPr lang="fr-FR" sz="1350" dirty="0">
+              <a:solidFill>
+                <a:prstClr val="white"/>
+              </a:solidFill>
+              <a:latin typeface="Calibri" panose="020F0502020204030204"/>
+            </a:endParaRPr>
+          </a:p>
+        </p:txBody>
+      </p:sp>
+      <p:sp>
+        <p:nvSpPr>
+          <p:cNvPr id="2" name="Titre 1">
+            <a:extLst>
+              <a:ext uri="{FF2B5EF4-FFF2-40B4-BE49-F238E27FC236}">
+                <a16:creationId xmlns:a16="http://schemas.microsoft.com/office/drawing/2014/main" id="{8059E6FA-5ED7-4859-9321-2086931B31A3}"/>
+              </a:ext>
+            </a:extLst>
+          </p:cNvPr>
+          <p:cNvSpPr>
+            <a:spLocks noGrp="1"/>
+          </p:cNvSpPr>
+          <p:nvPr>
+            <p:ph type="title"/>
+          </p:nvPr>
+        </p:nvSpPr>
+        <p:spPr/>
+        <p:txBody>
+          <a:bodyPr>
+            <a:normAutofit fontScale="90000"/>
+          </a:bodyPr>
+          <a:lstStyle/>
+          <a:p>
+            <a:r>
+              <a:rPr lang="fr-FR" dirty="0"/>
+              <a:t>Gamme de couleurs pour température</a:t>
+            </a:r>
+            <a:br>
+              <a:rPr lang="fr-FR" dirty="0"/>
+            </a:br>
+            <a:r>
+              <a:rPr lang="fr-FR" dirty="0"/>
+              <a:t>04.05.2026</a:t>
+            </a:r>
+          </a:p>
+        </p:txBody>
+      </p:sp>
+      <p:sp>
+        <p:nvSpPr>
+          <p:cNvPr id="25" name="Rectangle 24">
+            <a:extLst>
+              <a:ext uri="{FF2B5EF4-FFF2-40B4-BE49-F238E27FC236}">
+                <a16:creationId xmlns:a16="http://schemas.microsoft.com/office/drawing/2014/main" id="{180B77EA-ECCE-4809-86D7-2D88840298AB}"/>
+              </a:ext>
+            </a:extLst>
+          </p:cNvPr>
+          <p:cNvSpPr/>
+          <p:nvPr/>
+        </p:nvSpPr>
+        <p:spPr>
+          <a:xfrm>
+            <a:off x="5923197" y="1116746"/>
+            <a:ext cx="288032" cy="288032"/>
+          </a:xfrm>
+          <a:prstGeom prst="rect">
+            <a:avLst/>
+          </a:prstGeom>
+          <a:solidFill>
+            <a:schemeClr val="bg1"/>
+          </a:solidFill>
+        </p:spPr>
+        <p:style>
+          <a:lnRef idx="2">
+            <a:schemeClr val="accent1">
+              <a:shade val="50000"/>
+            </a:schemeClr>
+          </a:lnRef>
+          <a:fillRef idx="1">
+            <a:schemeClr val="accent1"/>
+          </a:fillRef>
+          <a:effectRef idx="0">
+            <a:schemeClr val="accent1"/>
+          </a:effectRef>
+          <a:fontRef idx="minor">
+            <a:schemeClr val="lt1"/>
+          </a:fontRef>
+        </p:style>
+        <p:txBody>
+          <a:bodyPr rtlCol="0" anchor="ctr"/>
+          <a:lstStyle/>
+          <a:p>
+            <a:pPr algn="ctr"/>
+            <a:endParaRPr lang="fr-FR"/>
+          </a:p>
+        </p:txBody>
+      </p:sp>
+      <p:sp>
+        <p:nvSpPr>
+          <p:cNvPr id="26" name="Rectangle 25">
+            <a:extLst>
+              <a:ext uri="{FF2B5EF4-FFF2-40B4-BE49-F238E27FC236}">
+                <a16:creationId xmlns:a16="http://schemas.microsoft.com/office/drawing/2014/main" id="{3F0753EE-E706-4737-9865-F37076117640}"/>
+              </a:ext>
+            </a:extLst>
+          </p:cNvPr>
+          <p:cNvSpPr/>
+          <p:nvPr/>
+        </p:nvSpPr>
+        <p:spPr>
+          <a:xfrm>
+            <a:off x="3187915" y="1116746"/>
+            <a:ext cx="288032" cy="288032"/>
+          </a:xfrm>
+          <a:prstGeom prst="rect">
+            <a:avLst/>
+          </a:prstGeom>
+          <a:solidFill>
+            <a:srgbClr val="000AF3"/>
+          </a:solidFill>
+        </p:spPr>
+        <p:style>
+          <a:lnRef idx="2">
+            <a:schemeClr val="accent1">
+              <a:shade val="50000"/>
+            </a:schemeClr>
+          </a:lnRef>
+          <a:fillRef idx="1">
+            <a:schemeClr val="accent1"/>
+          </a:fillRef>
+          <a:effectRef idx="0">
+            <a:schemeClr val="accent1"/>
+          </a:effectRef>
+          <a:fontRef idx="minor">
+            <a:schemeClr val="lt1"/>
+          </a:fontRef>
+        </p:style>
+        <p:txBody>
+          <a:bodyPr rtlCol="0" anchor="ctr"/>
+          <a:lstStyle/>
+          <a:p>
+            <a:pPr algn="ctr"/>
+            <a:endParaRPr lang="fr-FR"/>
+          </a:p>
+        </p:txBody>
+      </p:sp>
+      <p:sp>
+        <p:nvSpPr>
+          <p:cNvPr id="27" name="Rectangle 26">
+            <a:extLst>
+              <a:ext uri="{FF2B5EF4-FFF2-40B4-BE49-F238E27FC236}">
+                <a16:creationId xmlns:a16="http://schemas.microsoft.com/office/drawing/2014/main" id="{88CE9E63-D487-494F-AC48-866655A1006B}"/>
+              </a:ext>
+            </a:extLst>
+          </p:cNvPr>
+          <p:cNvSpPr/>
+          <p:nvPr/>
+        </p:nvSpPr>
+        <p:spPr>
+          <a:xfrm>
+            <a:off x="3578670" y="1116746"/>
+            <a:ext cx="288032" cy="288032"/>
+          </a:xfrm>
+          <a:prstGeom prst="rect">
+            <a:avLst/>
+          </a:prstGeom>
+          <a:solidFill>
+            <a:srgbClr val="00AF51"/>
+          </a:solidFill>
+        </p:spPr>
+        <p:style>
+          <a:lnRef idx="2">
+            <a:schemeClr val="accent1">
+              <a:shade val="50000"/>
+            </a:schemeClr>
+          </a:lnRef>
+          <a:fillRef idx="1">
+            <a:schemeClr val="accent1"/>
+          </a:fillRef>
+          <a:effectRef idx="0">
+            <a:schemeClr val="accent1"/>
+          </a:effectRef>
+          <a:fontRef idx="minor">
+            <a:schemeClr val="lt1"/>
+          </a:fontRef>
+        </p:style>
+        <p:txBody>
+          <a:bodyPr rtlCol="0" anchor="ctr"/>
+          <a:lstStyle/>
+          <a:p>
+            <a:pPr algn="ctr"/>
+            <a:endParaRPr lang="fr-FR"/>
+          </a:p>
+        </p:txBody>
+      </p:sp>
+      <p:sp>
+        <p:nvSpPr>
+          <p:cNvPr id="28" name="Rectangle 27">
+            <a:extLst>
+              <a:ext uri="{FF2B5EF4-FFF2-40B4-BE49-F238E27FC236}">
+                <a16:creationId xmlns:a16="http://schemas.microsoft.com/office/drawing/2014/main" id="{FAF496D8-523A-4FD4-90CA-E86BE8A49548}"/>
+              </a:ext>
+            </a:extLst>
+          </p:cNvPr>
+          <p:cNvSpPr/>
+          <p:nvPr/>
+        </p:nvSpPr>
+        <p:spPr>
+          <a:xfrm>
+            <a:off x="3969425" y="1116746"/>
+            <a:ext cx="288032" cy="288032"/>
+          </a:xfrm>
+          <a:prstGeom prst="rect">
+            <a:avLst/>
+          </a:prstGeom>
+          <a:solidFill>
+            <a:srgbClr val="3EFF00"/>
+          </a:solidFill>
+        </p:spPr>
+        <p:style>
+          <a:lnRef idx="2">
+            <a:schemeClr val="accent1">
+              <a:shade val="50000"/>
+            </a:schemeClr>
+          </a:lnRef>
+          <a:fillRef idx="1">
+            <a:schemeClr val="accent1"/>
+          </a:fillRef>
+          <a:effectRef idx="0">
+            <a:schemeClr val="accent1"/>
+          </a:effectRef>
+          <a:fontRef idx="minor">
+            <a:schemeClr val="lt1"/>
+          </a:fontRef>
+        </p:style>
+        <p:txBody>
+          <a:bodyPr rtlCol="0" anchor="ctr"/>
+          <a:lstStyle/>
+          <a:p>
+            <a:pPr algn="ctr"/>
+            <a:endParaRPr lang="fr-FR"/>
+          </a:p>
+        </p:txBody>
+      </p:sp>
+      <p:sp>
+        <p:nvSpPr>
+          <p:cNvPr id="29" name="Rectangle 28">
+            <a:extLst>
+              <a:ext uri="{FF2B5EF4-FFF2-40B4-BE49-F238E27FC236}">
+                <a16:creationId xmlns:a16="http://schemas.microsoft.com/office/drawing/2014/main" id="{ED0E25C1-D1F4-4F0F-994E-8D7869F9ACF5}"/>
+              </a:ext>
+            </a:extLst>
+          </p:cNvPr>
+          <p:cNvSpPr/>
+          <p:nvPr/>
+        </p:nvSpPr>
+        <p:spPr>
+          <a:xfrm>
+            <a:off x="4360180" y="1116746"/>
+            <a:ext cx="288032" cy="288032"/>
+          </a:xfrm>
+          <a:prstGeom prst="rect">
+            <a:avLst/>
+          </a:prstGeom>
+          <a:solidFill>
+            <a:srgbClr val="FFFB01"/>
+          </a:solidFill>
+        </p:spPr>
+        <p:style>
+          <a:lnRef idx="2">
+            <a:schemeClr val="accent1">
+              <a:shade val="50000"/>
+            </a:schemeClr>
+          </a:lnRef>
+          <a:fillRef idx="1">
+            <a:schemeClr val="accent1"/>
+          </a:fillRef>
+          <a:effectRef idx="0">
+            <a:schemeClr val="accent1"/>
+          </a:effectRef>
+          <a:fontRef idx="minor">
+            <a:schemeClr val="lt1"/>
+          </a:fontRef>
+        </p:style>
+        <p:txBody>
+          <a:bodyPr rtlCol="0" anchor="ctr"/>
+          <a:lstStyle/>
+          <a:p>
+            <a:pPr algn="ctr"/>
+            <a:endParaRPr lang="fr-FR"/>
+          </a:p>
+        </p:txBody>
+      </p:sp>
+      <p:sp>
+        <p:nvSpPr>
+          <p:cNvPr id="30" name="Rectangle 29">
+            <a:extLst>
+              <a:ext uri="{FF2B5EF4-FFF2-40B4-BE49-F238E27FC236}">
+                <a16:creationId xmlns:a16="http://schemas.microsoft.com/office/drawing/2014/main" id="{A518501A-D9F4-44A4-8AE4-F0062E452197}"/>
+              </a:ext>
+            </a:extLst>
+          </p:cNvPr>
+          <p:cNvSpPr/>
+          <p:nvPr/>
+        </p:nvSpPr>
+        <p:spPr>
+          <a:xfrm>
+            <a:off x="4750935" y="1116746"/>
+            <a:ext cx="288032" cy="288032"/>
+          </a:xfrm>
+          <a:prstGeom prst="rect">
+            <a:avLst/>
+          </a:prstGeom>
+          <a:solidFill>
+            <a:srgbClr val="FFA800"/>
+          </a:solidFill>
+        </p:spPr>
+        <p:style>
+          <a:lnRef idx="2">
+            <a:schemeClr val="accent1">
+              <a:shade val="50000"/>
+            </a:schemeClr>
+          </a:lnRef>
+          <a:fillRef idx="1">
+            <a:schemeClr val="accent1"/>
+          </a:fillRef>
+          <a:effectRef idx="0">
+            <a:schemeClr val="accent1"/>
+          </a:effectRef>
+          <a:fontRef idx="minor">
+            <a:schemeClr val="lt1"/>
+          </a:fontRef>
+        </p:style>
+        <p:txBody>
+          <a:bodyPr rtlCol="0" anchor="ctr"/>
+          <a:lstStyle/>
+          <a:p>
+            <a:pPr algn="ctr"/>
+            <a:endParaRPr lang="fr-FR"/>
+          </a:p>
+        </p:txBody>
+      </p:sp>
+      <p:sp>
+        <p:nvSpPr>
+          <p:cNvPr id="31" name="Rectangle 30">
+            <a:extLst>
+              <a:ext uri="{FF2B5EF4-FFF2-40B4-BE49-F238E27FC236}">
+                <a16:creationId xmlns:a16="http://schemas.microsoft.com/office/drawing/2014/main" id="{5B8EC6C5-04EE-4FAB-A4A6-46FFA764FDF2}"/>
+              </a:ext>
+            </a:extLst>
+          </p:cNvPr>
+          <p:cNvSpPr/>
+          <p:nvPr/>
+        </p:nvSpPr>
+        <p:spPr>
+          <a:xfrm>
+            <a:off x="5141690" y="1116746"/>
+            <a:ext cx="288032" cy="288032"/>
+          </a:xfrm>
+          <a:prstGeom prst="rect">
+            <a:avLst/>
+          </a:prstGeom>
+          <a:solidFill>
+            <a:srgbClr val="FF6D00"/>
+          </a:solidFill>
+        </p:spPr>
+        <p:style>
+          <a:lnRef idx="2">
+            <a:schemeClr val="accent1">
+              <a:shade val="50000"/>
+            </a:schemeClr>
+          </a:lnRef>
+          <a:fillRef idx="1">
+            <a:schemeClr val="accent1"/>
+          </a:fillRef>
+          <a:effectRef idx="0">
+            <a:schemeClr val="accent1"/>
+          </a:effectRef>
+          <a:fontRef idx="minor">
+            <a:schemeClr val="lt1"/>
+          </a:fontRef>
+        </p:style>
+        <p:txBody>
+          <a:bodyPr rtlCol="0" anchor="ctr"/>
+          <a:lstStyle/>
+          <a:p>
+            <a:pPr algn="ctr"/>
+            <a:endParaRPr lang="fr-FR"/>
+          </a:p>
+        </p:txBody>
+      </p:sp>
+      <p:sp>
+        <p:nvSpPr>
+          <p:cNvPr id="32" name="Rectangle 31">
+            <a:extLst>
+              <a:ext uri="{FF2B5EF4-FFF2-40B4-BE49-F238E27FC236}">
+                <a16:creationId xmlns:a16="http://schemas.microsoft.com/office/drawing/2014/main" id="{7E23A5A8-2505-4BFC-9B1E-00AEB6A07958}"/>
+              </a:ext>
+            </a:extLst>
+          </p:cNvPr>
+          <p:cNvSpPr/>
+          <p:nvPr/>
+        </p:nvSpPr>
+        <p:spPr>
+          <a:xfrm>
+            <a:off x="5532445" y="1116746"/>
+            <a:ext cx="288032" cy="288032"/>
+          </a:xfrm>
+          <a:prstGeom prst="rect">
+            <a:avLst/>
+          </a:prstGeom>
+          <a:solidFill>
+            <a:srgbClr val="FE1100"/>
+          </a:solidFill>
+        </p:spPr>
+        <p:style>
+          <a:lnRef idx="2">
+            <a:schemeClr val="accent1">
+              <a:shade val="50000"/>
+            </a:schemeClr>
+          </a:lnRef>
+          <a:fillRef idx="1">
+            <a:schemeClr val="accent1"/>
+          </a:fillRef>
+          <a:effectRef idx="0">
+            <a:schemeClr val="accent1"/>
+          </a:effectRef>
+          <a:fontRef idx="minor">
+            <a:schemeClr val="lt1"/>
+          </a:fontRef>
+        </p:style>
+        <p:txBody>
+          <a:bodyPr rtlCol="0" anchor="ctr"/>
+          <a:lstStyle/>
+          <a:p>
+            <a:pPr algn="ctr"/>
+            <a:endParaRPr lang="fr-FR"/>
+          </a:p>
+        </p:txBody>
+      </p:sp>
+      <p:sp>
+        <p:nvSpPr>
+          <p:cNvPr id="33" name="Rectangle 32">
+            <a:extLst>
+              <a:ext uri="{FF2B5EF4-FFF2-40B4-BE49-F238E27FC236}">
+                <a16:creationId xmlns:a16="http://schemas.microsoft.com/office/drawing/2014/main" id="{19A555FB-8069-47D1-AB9F-188EAF408B8A}"/>
+              </a:ext>
+            </a:extLst>
+          </p:cNvPr>
+          <p:cNvSpPr/>
+          <p:nvPr/>
+        </p:nvSpPr>
+        <p:spPr>
+          <a:xfrm>
+            <a:off x="5923197" y="1116746"/>
+            <a:ext cx="288032" cy="288032"/>
+          </a:xfrm>
+          <a:prstGeom prst="rect">
+            <a:avLst/>
+          </a:prstGeom>
+          <a:solidFill>
+            <a:schemeClr val="bg1"/>
+          </a:solidFill>
+        </p:spPr>
+        <p:style>
+          <a:lnRef idx="2">
+            <a:schemeClr val="accent1">
+              <a:shade val="50000"/>
+            </a:schemeClr>
+          </a:lnRef>
+          <a:fillRef idx="1">
+            <a:schemeClr val="accent1"/>
+          </a:fillRef>
+          <a:effectRef idx="0">
+            <a:schemeClr val="accent1"/>
+          </a:effectRef>
+          <a:fontRef idx="minor">
+            <a:schemeClr val="lt1"/>
+          </a:fontRef>
+        </p:style>
+        <p:txBody>
+          <a:bodyPr rtlCol="0" anchor="ctr"/>
+          <a:lstStyle/>
+          <a:p>
+            <a:pPr algn="ctr"/>
+            <a:endParaRPr lang="fr-FR"/>
+          </a:p>
+        </p:txBody>
+      </p:sp>
+      <p:sp>
+        <p:nvSpPr>
+          <p:cNvPr id="34" name="ZoneTexte 33">
+            <a:extLst>
+              <a:ext uri="{FF2B5EF4-FFF2-40B4-BE49-F238E27FC236}">
+                <a16:creationId xmlns:a16="http://schemas.microsoft.com/office/drawing/2014/main" id="{34E355B1-FC9A-43F3-B824-07AAA4E52BDA}"/>
+              </a:ext>
+            </a:extLst>
+          </p:cNvPr>
+          <p:cNvSpPr txBox="1"/>
+          <p:nvPr/>
+        </p:nvSpPr>
+        <p:spPr>
+          <a:xfrm>
+            <a:off x="-52894" y="2985025"/>
+            <a:ext cx="1812099" cy="707886"/>
+          </a:xfrm>
+          <a:prstGeom prst="rect">
+            <a:avLst/>
+          </a:prstGeom>
+          <a:noFill/>
+        </p:spPr>
+        <p:txBody>
+          <a:bodyPr wrap="none" rtlCol="0">
+            <a:spAutoFit/>
+          </a:bodyPr>
+          <a:lstStyle/>
+          <a:p>
+            <a:pPr algn="ctr"/>
+            <a:r>
+              <a:rPr lang="fr-FR" sz="2000" dirty="0" err="1">
+                <a:latin typeface="+mj-lt"/>
+              </a:rPr>
+              <a:t>Sea</a:t>
+            </a:r>
+            <a:r>
+              <a:rPr lang="fr-FR" sz="2000" dirty="0">
+                <a:latin typeface="+mj-lt"/>
+              </a:rPr>
+              <a:t>-surface</a:t>
+            </a:r>
+            <a:br>
+              <a:rPr lang="fr-FR" sz="2000" dirty="0">
+                <a:latin typeface="+mj-lt"/>
+              </a:rPr>
+            </a:br>
+            <a:r>
+              <a:rPr lang="fr-FR" sz="2000" dirty="0" err="1">
+                <a:latin typeface="+mj-lt"/>
+              </a:rPr>
+              <a:t>temperature</a:t>
+            </a:r>
+            <a:r>
+              <a:rPr lang="fr-FR" sz="2000" dirty="0">
+                <a:latin typeface="+mj-lt"/>
+              </a:rPr>
+              <a:t> °C</a:t>
+            </a:r>
+            <a:endParaRPr lang="fr-FR" sz="2000" baseline="30000" dirty="0">
+              <a:latin typeface="+mj-lt"/>
+            </a:endParaRPr>
+          </a:p>
+        </p:txBody>
+      </p:sp>
+      <p:sp>
+        <p:nvSpPr>
+          <p:cNvPr id="35" name="ZoneTexte 34">
+            <a:extLst>
+              <a:ext uri="{FF2B5EF4-FFF2-40B4-BE49-F238E27FC236}">
+                <a16:creationId xmlns:a16="http://schemas.microsoft.com/office/drawing/2014/main" id="{2E7F5A6D-96F4-47F3-B4DA-A8905E1E8DD8}"/>
+              </a:ext>
+            </a:extLst>
+          </p:cNvPr>
+          <p:cNvSpPr txBox="1"/>
+          <p:nvPr/>
+        </p:nvSpPr>
+        <p:spPr>
+          <a:xfrm>
+            <a:off x="3548973" y="1413781"/>
+            <a:ext cx="359394" cy="369332"/>
+          </a:xfrm>
+          <a:prstGeom prst="rect">
+            <a:avLst/>
+          </a:prstGeom>
+          <a:noFill/>
+        </p:spPr>
+        <p:txBody>
+          <a:bodyPr wrap="none" rtlCol="0">
+            <a:spAutoFit/>
+          </a:bodyPr>
+          <a:lstStyle/>
+          <a:p>
+            <a:r>
+              <a:rPr lang="fr-FR" dirty="0"/>
+              <a:t>.2</a:t>
+            </a:r>
+          </a:p>
+        </p:txBody>
+      </p:sp>
+      <p:sp>
+        <p:nvSpPr>
+          <p:cNvPr id="36" name="ZoneTexte 35">
+            <a:extLst>
+              <a:ext uri="{FF2B5EF4-FFF2-40B4-BE49-F238E27FC236}">
+                <a16:creationId xmlns:a16="http://schemas.microsoft.com/office/drawing/2014/main" id="{F51E41E7-58F4-4906-ACD3-24253361691C}"/>
+              </a:ext>
+            </a:extLst>
+          </p:cNvPr>
+          <p:cNvSpPr txBox="1"/>
+          <p:nvPr/>
+        </p:nvSpPr>
+        <p:spPr>
+          <a:xfrm>
+            <a:off x="3909013" y="1413781"/>
+            <a:ext cx="359394" cy="369332"/>
+          </a:xfrm>
+          <a:prstGeom prst="rect">
+            <a:avLst/>
+          </a:prstGeom>
+          <a:noFill/>
+        </p:spPr>
+        <p:txBody>
+          <a:bodyPr wrap="none" rtlCol="0">
+            <a:spAutoFit/>
+          </a:bodyPr>
+          <a:lstStyle/>
+          <a:p>
+            <a:r>
+              <a:rPr lang="fr-FR" dirty="0"/>
+              <a:t>.5</a:t>
+            </a:r>
+          </a:p>
+        </p:txBody>
+      </p:sp>
+      <p:sp>
+        <p:nvSpPr>
+          <p:cNvPr id="37" name="ZoneTexte 36">
+            <a:extLst>
+              <a:ext uri="{FF2B5EF4-FFF2-40B4-BE49-F238E27FC236}">
+                <a16:creationId xmlns:a16="http://schemas.microsoft.com/office/drawing/2014/main" id="{C0E751E8-7C4E-4146-B834-48692C2C7FFD}"/>
+              </a:ext>
+            </a:extLst>
+          </p:cNvPr>
+          <p:cNvSpPr txBox="1"/>
+          <p:nvPr/>
+        </p:nvSpPr>
+        <p:spPr>
+          <a:xfrm>
+            <a:off x="4341061" y="1413781"/>
+            <a:ext cx="359394" cy="369332"/>
+          </a:xfrm>
+          <a:prstGeom prst="rect">
+            <a:avLst/>
+          </a:prstGeom>
+          <a:noFill/>
+        </p:spPr>
+        <p:txBody>
+          <a:bodyPr wrap="none" rtlCol="0">
+            <a:spAutoFit/>
+          </a:bodyPr>
+          <a:lstStyle/>
+          <a:p>
+            <a:r>
+              <a:rPr lang="fr-FR" dirty="0"/>
+              <a:t>1.</a:t>
+            </a:r>
+          </a:p>
+        </p:txBody>
+      </p:sp>
+      <p:sp>
+        <p:nvSpPr>
+          <p:cNvPr id="38" name="ZoneTexte 37">
+            <a:extLst>
+              <a:ext uri="{FF2B5EF4-FFF2-40B4-BE49-F238E27FC236}">
+                <a16:creationId xmlns:a16="http://schemas.microsoft.com/office/drawing/2014/main" id="{4F7C15C8-1DD2-4494-8528-BB9FE83D9D51}"/>
+              </a:ext>
+            </a:extLst>
+          </p:cNvPr>
+          <p:cNvSpPr txBox="1"/>
+          <p:nvPr/>
+        </p:nvSpPr>
+        <p:spPr>
+          <a:xfrm>
+            <a:off x="4656091" y="1413781"/>
+            <a:ext cx="476412" cy="369332"/>
+          </a:xfrm>
+          <a:prstGeom prst="rect">
+            <a:avLst/>
+          </a:prstGeom>
+          <a:noFill/>
+        </p:spPr>
+        <p:txBody>
+          <a:bodyPr wrap="none" rtlCol="0">
+            <a:spAutoFit/>
+          </a:bodyPr>
+          <a:lstStyle/>
+          <a:p>
+            <a:r>
+              <a:rPr lang="fr-FR" dirty="0"/>
+              <a:t>1.5</a:t>
+            </a:r>
+          </a:p>
+        </p:txBody>
+      </p:sp>
+      <p:sp>
+        <p:nvSpPr>
+          <p:cNvPr id="39" name="ZoneTexte 38">
+            <a:extLst>
+              <a:ext uri="{FF2B5EF4-FFF2-40B4-BE49-F238E27FC236}">
+                <a16:creationId xmlns:a16="http://schemas.microsoft.com/office/drawing/2014/main" id="{7679C794-5CBA-405F-B27F-425A58C9A5D8}"/>
+              </a:ext>
+            </a:extLst>
+          </p:cNvPr>
+          <p:cNvSpPr txBox="1"/>
+          <p:nvPr/>
+        </p:nvSpPr>
+        <p:spPr>
+          <a:xfrm>
+            <a:off x="5097262" y="1413781"/>
+            <a:ext cx="359394" cy="369332"/>
+          </a:xfrm>
+          <a:prstGeom prst="rect">
+            <a:avLst/>
+          </a:prstGeom>
+          <a:noFill/>
+        </p:spPr>
+        <p:txBody>
+          <a:bodyPr wrap="none" rtlCol="0">
+            <a:spAutoFit/>
+          </a:bodyPr>
+          <a:lstStyle/>
+          <a:p>
+            <a:r>
+              <a:rPr lang="fr-FR" dirty="0"/>
+              <a:t>2.</a:t>
+            </a:r>
+          </a:p>
+        </p:txBody>
+      </p:sp>
+      <p:sp>
+        <p:nvSpPr>
+          <p:cNvPr id="40" name="ZoneTexte 39">
+            <a:extLst>
+              <a:ext uri="{FF2B5EF4-FFF2-40B4-BE49-F238E27FC236}">
+                <a16:creationId xmlns:a16="http://schemas.microsoft.com/office/drawing/2014/main" id="{9B8D997C-A1CF-4A29-9EEA-F1A5208B5832}"/>
+              </a:ext>
+            </a:extLst>
+          </p:cNvPr>
+          <p:cNvSpPr txBox="1"/>
+          <p:nvPr/>
+        </p:nvSpPr>
+        <p:spPr>
+          <a:xfrm>
+            <a:off x="5465998" y="1413781"/>
+            <a:ext cx="417102" cy="369332"/>
+          </a:xfrm>
+          <a:prstGeom prst="rect">
+            <a:avLst/>
+          </a:prstGeom>
+          <a:noFill/>
+        </p:spPr>
+        <p:txBody>
+          <a:bodyPr wrap="none" rtlCol="0">
+            <a:spAutoFit/>
+          </a:bodyPr>
+          <a:lstStyle/>
+          <a:p>
+            <a:r>
+              <a:rPr lang="fr-FR" dirty="0"/>
+              <a:t>&gt;3</a:t>
+            </a:r>
+          </a:p>
+        </p:txBody>
+      </p:sp>
+      <p:sp>
+        <p:nvSpPr>
+          <p:cNvPr id="41" name="ZoneTexte 40">
+            <a:extLst>
+              <a:ext uri="{FF2B5EF4-FFF2-40B4-BE49-F238E27FC236}">
+                <a16:creationId xmlns:a16="http://schemas.microsoft.com/office/drawing/2014/main" id="{93A023DE-035F-41BB-A13B-CC5A48C8436F}"/>
+              </a:ext>
+            </a:extLst>
+          </p:cNvPr>
+          <p:cNvSpPr txBox="1"/>
+          <p:nvPr/>
+        </p:nvSpPr>
+        <p:spPr>
+          <a:xfrm>
+            <a:off x="3058551" y="1413781"/>
+            <a:ext cx="474810" cy="369332"/>
+          </a:xfrm>
+          <a:prstGeom prst="rect">
+            <a:avLst/>
+          </a:prstGeom>
+          <a:noFill/>
+        </p:spPr>
+        <p:txBody>
+          <a:bodyPr wrap="none" rtlCol="0">
+            <a:spAutoFit/>
+          </a:bodyPr>
+          <a:lstStyle/>
+          <a:p>
+            <a:r>
+              <a:rPr lang="fr-FR" dirty="0"/>
+              <a:t>&lt;.2</a:t>
+            </a:r>
+          </a:p>
+        </p:txBody>
+      </p:sp>
+      <p:sp>
+        <p:nvSpPr>
+          <p:cNvPr id="42" name="ZoneTexte 41">
+            <a:extLst>
+              <a:ext uri="{FF2B5EF4-FFF2-40B4-BE49-F238E27FC236}">
+                <a16:creationId xmlns:a16="http://schemas.microsoft.com/office/drawing/2014/main" id="{679C1387-79C0-4FE0-9058-8E1888447445}"/>
+              </a:ext>
+            </a:extLst>
+          </p:cNvPr>
+          <p:cNvSpPr txBox="1"/>
+          <p:nvPr/>
+        </p:nvSpPr>
+        <p:spPr>
+          <a:xfrm>
+            <a:off x="5853463" y="1444558"/>
+            <a:ext cx="502061" cy="307777"/>
+          </a:xfrm>
+          <a:prstGeom prst="rect">
+            <a:avLst/>
+          </a:prstGeom>
+          <a:noFill/>
+        </p:spPr>
+        <p:txBody>
+          <a:bodyPr wrap="none" rtlCol="0">
+            <a:spAutoFit/>
+          </a:bodyPr>
+          <a:lstStyle/>
+          <a:p>
+            <a:r>
+              <a:rPr lang="fr-FR" sz="1400" dirty="0"/>
+              <a:t>land</a:t>
+            </a:r>
+          </a:p>
+        </p:txBody>
+      </p:sp>
+      <p:sp>
+        <p:nvSpPr>
+          <p:cNvPr id="5" name="Rectangle 4">
+            <a:extLst>
+              <a:ext uri="{FF2B5EF4-FFF2-40B4-BE49-F238E27FC236}">
+                <a16:creationId xmlns:a16="http://schemas.microsoft.com/office/drawing/2014/main" id="{03DC80F8-B02C-4EE7-AE0F-3E0F7F9A81B0}"/>
+              </a:ext>
+            </a:extLst>
+          </p:cNvPr>
+          <p:cNvSpPr/>
+          <p:nvPr/>
+        </p:nvSpPr>
+        <p:spPr>
+          <a:xfrm>
+            <a:off x="1814513" y="3140968"/>
+            <a:ext cx="423569" cy="396000"/>
+          </a:xfrm>
+          <a:prstGeom prst="rect">
+            <a:avLst/>
+          </a:prstGeom>
+          <a:noFill/>
+          <a:ln w="9525"/>
+        </p:spPr>
+        <p:style>
+          <a:lnRef idx="2">
+            <a:schemeClr val="accent1">
+              <a:shade val="50000"/>
+            </a:schemeClr>
+          </a:lnRef>
+          <a:fillRef idx="1">
+            <a:schemeClr val="accent1"/>
+          </a:fillRef>
+          <a:effectRef idx="0">
+            <a:schemeClr val="accent1"/>
+          </a:effectRef>
+          <a:fontRef idx="minor">
+            <a:schemeClr val="lt1"/>
+          </a:fontRef>
+        </p:style>
+        <p:txBody>
+          <a:bodyPr rot="0" spcFirstLastPara="0" vertOverflow="overflow" horzOverflow="overflow" vert="horz" wrap="square" lIns="68580" tIns="34290" rIns="68580" bIns="34290" numCol="1" spcCol="0" rtlCol="0" fromWordArt="0" anchor="ctr" anchorCtr="0" forceAA="0" compatLnSpc="1">
+            <a:prstTxWarp prst="textNoShape">
+              <a:avLst/>
+            </a:prstTxWarp>
+            <a:noAutofit/>
+          </a:bodyPr>
+          <a:lstStyle/>
+          <a:p>
+            <a:pPr algn="ctr" defTabSz="685800"/>
+            <a:r>
+              <a:rPr lang="fr-FR" sz="1350" dirty="0">
+                <a:ln w="0"/>
+                <a:solidFill>
+                  <a:schemeClr val="tx1"/>
+                </a:solidFill>
+                <a:effectLst>
+                  <a:outerShdw blurRad="38100" dist="19050" dir="2700000" algn="tl" rotWithShape="0">
+                    <a:schemeClr val="dk1">
+                      <a:alpha val="40000"/>
+                    </a:schemeClr>
+                  </a:outerShdw>
+                </a:effectLst>
+                <a:latin typeface="Calibri" panose="020F0502020204030204"/>
+              </a:rPr>
+              <a:t>19</a:t>
+            </a:r>
+          </a:p>
+        </p:txBody>
+      </p:sp>
+      <p:sp>
+        <p:nvSpPr>
+          <p:cNvPr id="6" name="Rectangle 5">
+            <a:extLst>
+              <a:ext uri="{FF2B5EF4-FFF2-40B4-BE49-F238E27FC236}">
+                <a16:creationId xmlns:a16="http://schemas.microsoft.com/office/drawing/2014/main" id="{46C66F71-8875-46F8-8A60-CB042CEA5E39}"/>
+              </a:ext>
+            </a:extLst>
+          </p:cNvPr>
+          <p:cNvSpPr/>
+          <p:nvPr/>
+        </p:nvSpPr>
+        <p:spPr>
+          <a:xfrm>
+            <a:off x="2239972" y="3140968"/>
+            <a:ext cx="423569" cy="396000"/>
+          </a:xfrm>
+          <a:prstGeom prst="rect">
+            <a:avLst/>
+          </a:prstGeom>
+          <a:noFill/>
+          <a:ln w="9525"/>
+        </p:spPr>
+        <p:style>
+          <a:lnRef idx="2">
+            <a:schemeClr val="accent1">
+              <a:shade val="50000"/>
+            </a:schemeClr>
+          </a:lnRef>
+          <a:fillRef idx="1">
+            <a:schemeClr val="accent1"/>
+          </a:fillRef>
+          <a:effectRef idx="0">
+            <a:schemeClr val="accent1"/>
+          </a:effectRef>
+          <a:fontRef idx="minor">
+            <a:schemeClr val="lt1"/>
+          </a:fontRef>
+        </p:style>
+        <p:txBody>
+          <a:bodyPr rot="0" spcFirstLastPara="0" vertOverflow="overflow" horzOverflow="overflow" vert="horz" wrap="square" lIns="68580" tIns="34290" rIns="68580" bIns="34290" numCol="1" spcCol="0" rtlCol="0" fromWordArt="0" anchor="ctr" anchorCtr="0" forceAA="0" compatLnSpc="1">
+            <a:prstTxWarp prst="textNoShape">
+              <a:avLst/>
+            </a:prstTxWarp>
+            <a:noAutofit/>
+          </a:bodyPr>
+          <a:lstStyle/>
+          <a:p>
+            <a:pPr algn="ctr" defTabSz="685800"/>
+            <a:r>
+              <a:rPr lang="fr-FR" sz="1350" dirty="0">
+                <a:ln w="0"/>
+                <a:solidFill>
+                  <a:schemeClr val="tx1"/>
+                </a:solidFill>
+                <a:effectLst>
+                  <a:outerShdw blurRad="38100" dist="19050" dir="2700000" algn="tl" rotWithShape="0">
+                    <a:schemeClr val="dk1">
+                      <a:alpha val="40000"/>
+                    </a:schemeClr>
+                  </a:outerShdw>
+                </a:effectLst>
+                <a:latin typeface="Calibri" panose="020F0502020204030204"/>
+              </a:rPr>
+              <a:t>20</a:t>
+            </a:r>
+          </a:p>
+        </p:txBody>
+      </p:sp>
+      <p:sp>
+        <p:nvSpPr>
+          <p:cNvPr id="7" name="Rectangle 6">
+            <a:extLst>
+              <a:ext uri="{FF2B5EF4-FFF2-40B4-BE49-F238E27FC236}">
+                <a16:creationId xmlns:a16="http://schemas.microsoft.com/office/drawing/2014/main" id="{A1F761E1-AF4A-4FFE-B287-CB0502520D42}"/>
+              </a:ext>
+            </a:extLst>
+          </p:cNvPr>
+          <p:cNvSpPr/>
+          <p:nvPr/>
+        </p:nvSpPr>
+        <p:spPr>
+          <a:xfrm>
+            <a:off x="2665431" y="3140968"/>
+            <a:ext cx="423569" cy="396000"/>
+          </a:xfrm>
+          <a:prstGeom prst="rect">
+            <a:avLst/>
+          </a:prstGeom>
+          <a:noFill/>
+          <a:ln w="9525"/>
+        </p:spPr>
+        <p:style>
+          <a:lnRef idx="2">
+            <a:schemeClr val="accent1">
+              <a:shade val="50000"/>
+            </a:schemeClr>
+          </a:lnRef>
+          <a:fillRef idx="1">
+            <a:schemeClr val="accent1"/>
+          </a:fillRef>
+          <a:effectRef idx="0">
+            <a:schemeClr val="accent1"/>
+          </a:effectRef>
+          <a:fontRef idx="minor">
+            <a:schemeClr val="lt1"/>
+          </a:fontRef>
+        </p:style>
+        <p:txBody>
+          <a:bodyPr rot="0" spcFirstLastPara="0" vertOverflow="overflow" horzOverflow="overflow" vert="horz" wrap="square" lIns="68580" tIns="34290" rIns="68580" bIns="34290" numCol="1" spcCol="0" rtlCol="0" fromWordArt="0" anchor="ctr" anchorCtr="0" forceAA="0" compatLnSpc="1">
+            <a:prstTxWarp prst="textNoShape">
+              <a:avLst/>
+            </a:prstTxWarp>
+            <a:noAutofit/>
+          </a:bodyPr>
+          <a:lstStyle/>
+          <a:p>
+            <a:pPr algn="ctr" defTabSz="685800"/>
+            <a:r>
+              <a:rPr lang="fr-FR" sz="1350" dirty="0">
+                <a:ln w="0"/>
+                <a:solidFill>
+                  <a:schemeClr val="tx1"/>
+                </a:solidFill>
+                <a:effectLst>
+                  <a:outerShdw blurRad="38100" dist="19050" dir="2700000" algn="tl" rotWithShape="0">
+                    <a:schemeClr val="dk1">
+                      <a:alpha val="40000"/>
+                    </a:schemeClr>
+                  </a:outerShdw>
+                </a:effectLst>
+                <a:latin typeface="Calibri" panose="020F0502020204030204"/>
+              </a:rPr>
+              <a:t>21</a:t>
+            </a:r>
+          </a:p>
+        </p:txBody>
+      </p:sp>
+      <p:sp>
+        <p:nvSpPr>
+          <p:cNvPr id="8" name="Rectangle 7">
+            <a:extLst>
+              <a:ext uri="{FF2B5EF4-FFF2-40B4-BE49-F238E27FC236}">
+                <a16:creationId xmlns:a16="http://schemas.microsoft.com/office/drawing/2014/main" id="{83EF05A6-1ED4-4267-862E-6A810EBF9BF2}"/>
+              </a:ext>
+            </a:extLst>
+          </p:cNvPr>
+          <p:cNvSpPr/>
+          <p:nvPr/>
+        </p:nvSpPr>
+        <p:spPr>
+          <a:xfrm>
+            <a:off x="3090890" y="3140968"/>
+            <a:ext cx="423569" cy="396000"/>
+          </a:xfrm>
+          <a:prstGeom prst="rect">
+            <a:avLst/>
+          </a:prstGeom>
+          <a:noFill/>
+          <a:ln w="9525"/>
+        </p:spPr>
+        <p:style>
+          <a:lnRef idx="2">
+            <a:schemeClr val="accent1">
+              <a:shade val="50000"/>
+            </a:schemeClr>
+          </a:lnRef>
+          <a:fillRef idx="1">
+            <a:schemeClr val="accent1"/>
+          </a:fillRef>
+          <a:effectRef idx="0">
+            <a:schemeClr val="accent1"/>
+          </a:effectRef>
+          <a:fontRef idx="minor">
+            <a:schemeClr val="lt1"/>
+          </a:fontRef>
+        </p:style>
+        <p:txBody>
+          <a:bodyPr rot="0" spcFirstLastPara="0" vertOverflow="overflow" horzOverflow="overflow" vert="horz" wrap="square" lIns="68580" tIns="34290" rIns="68580" bIns="34290" numCol="1" spcCol="0" rtlCol="0" fromWordArt="0" anchor="ctr" anchorCtr="0" forceAA="0" compatLnSpc="1">
+            <a:prstTxWarp prst="textNoShape">
+              <a:avLst/>
+            </a:prstTxWarp>
+            <a:noAutofit/>
+          </a:bodyPr>
+          <a:lstStyle/>
+          <a:p>
+            <a:pPr algn="ctr" defTabSz="685800"/>
+            <a:r>
+              <a:rPr lang="fr-FR" sz="1350" dirty="0">
+                <a:ln w="0"/>
+                <a:solidFill>
+                  <a:schemeClr val="tx1"/>
+                </a:solidFill>
+                <a:effectLst>
+                  <a:outerShdw blurRad="38100" dist="19050" dir="2700000" algn="tl" rotWithShape="0">
+                    <a:schemeClr val="dk1">
+                      <a:alpha val="40000"/>
+                    </a:schemeClr>
+                  </a:outerShdw>
+                </a:effectLst>
+                <a:latin typeface="Calibri" panose="020F0502020204030204"/>
+              </a:rPr>
+              <a:t>22</a:t>
+            </a:r>
+          </a:p>
+        </p:txBody>
+      </p:sp>
+      <p:sp>
+        <p:nvSpPr>
+          <p:cNvPr id="9" name="Rectangle 8">
+            <a:extLst>
+              <a:ext uri="{FF2B5EF4-FFF2-40B4-BE49-F238E27FC236}">
+                <a16:creationId xmlns:a16="http://schemas.microsoft.com/office/drawing/2014/main" id="{22148DCB-56E3-42A2-AFEA-8CBA7D5EACBB}"/>
+              </a:ext>
+            </a:extLst>
+          </p:cNvPr>
+          <p:cNvSpPr/>
+          <p:nvPr/>
+        </p:nvSpPr>
+        <p:spPr>
+          <a:xfrm>
+            <a:off x="3516349" y="3140968"/>
+            <a:ext cx="423569" cy="396000"/>
+          </a:xfrm>
+          <a:prstGeom prst="rect">
+            <a:avLst/>
+          </a:prstGeom>
+          <a:noFill/>
+          <a:ln w="9525"/>
+        </p:spPr>
+        <p:style>
+          <a:lnRef idx="2">
+            <a:schemeClr val="accent1">
+              <a:shade val="50000"/>
+            </a:schemeClr>
+          </a:lnRef>
+          <a:fillRef idx="1">
+            <a:schemeClr val="accent1"/>
+          </a:fillRef>
+          <a:effectRef idx="0">
+            <a:schemeClr val="accent1"/>
+          </a:effectRef>
+          <a:fontRef idx="minor">
+            <a:schemeClr val="lt1"/>
+          </a:fontRef>
+        </p:style>
+        <p:txBody>
+          <a:bodyPr rot="0" spcFirstLastPara="0" vertOverflow="overflow" horzOverflow="overflow" vert="horz" wrap="square" lIns="68580" tIns="34290" rIns="68580" bIns="34290" numCol="1" spcCol="0" rtlCol="0" fromWordArt="0" anchor="ctr" anchorCtr="0" forceAA="0" compatLnSpc="1">
+            <a:prstTxWarp prst="textNoShape">
+              <a:avLst/>
+            </a:prstTxWarp>
+            <a:noAutofit/>
+          </a:bodyPr>
+          <a:lstStyle/>
+          <a:p>
+            <a:pPr algn="ctr" defTabSz="685800"/>
+            <a:r>
+              <a:rPr lang="fr-FR" sz="1350" dirty="0">
+                <a:ln w="0"/>
+                <a:solidFill>
+                  <a:schemeClr val="tx1"/>
+                </a:solidFill>
+                <a:effectLst>
+                  <a:outerShdw blurRad="38100" dist="19050" dir="2700000" algn="tl" rotWithShape="0">
+                    <a:schemeClr val="dk1">
+                      <a:alpha val="40000"/>
+                    </a:schemeClr>
+                  </a:outerShdw>
+                </a:effectLst>
+                <a:latin typeface="Calibri" panose="020F0502020204030204"/>
+              </a:rPr>
+              <a:t>23</a:t>
+            </a:r>
+          </a:p>
+        </p:txBody>
+      </p:sp>
+      <p:sp>
+        <p:nvSpPr>
+          <p:cNvPr id="10" name="Rectangle 9">
+            <a:extLst>
+              <a:ext uri="{FF2B5EF4-FFF2-40B4-BE49-F238E27FC236}">
+                <a16:creationId xmlns:a16="http://schemas.microsoft.com/office/drawing/2014/main" id="{80A3AB98-EF5F-488E-A53F-DB8AB76500DC}"/>
+              </a:ext>
+            </a:extLst>
+          </p:cNvPr>
+          <p:cNvSpPr/>
+          <p:nvPr/>
+        </p:nvSpPr>
+        <p:spPr>
+          <a:xfrm>
+            <a:off x="3941808" y="3140968"/>
+            <a:ext cx="423569" cy="396000"/>
+          </a:xfrm>
+          <a:prstGeom prst="rect">
+            <a:avLst/>
+          </a:prstGeom>
+          <a:noFill/>
+          <a:ln w="9525"/>
+        </p:spPr>
+        <p:style>
+          <a:lnRef idx="2">
+            <a:schemeClr val="accent1">
+              <a:shade val="50000"/>
+            </a:schemeClr>
+          </a:lnRef>
+          <a:fillRef idx="1">
+            <a:schemeClr val="accent1"/>
+          </a:fillRef>
+          <a:effectRef idx="0">
+            <a:schemeClr val="accent1"/>
+          </a:effectRef>
+          <a:fontRef idx="minor">
+            <a:schemeClr val="lt1"/>
+          </a:fontRef>
+        </p:style>
+        <p:txBody>
+          <a:bodyPr rot="0" spcFirstLastPara="0" vertOverflow="overflow" horzOverflow="overflow" vert="horz" wrap="square" lIns="68580" tIns="34290" rIns="68580" bIns="34290" numCol="1" spcCol="0" rtlCol="0" fromWordArt="0" anchor="ctr" anchorCtr="0" forceAA="0" compatLnSpc="1">
+            <a:prstTxWarp prst="textNoShape">
+              <a:avLst/>
+            </a:prstTxWarp>
+            <a:noAutofit/>
+          </a:bodyPr>
+          <a:lstStyle/>
+          <a:p>
+            <a:pPr algn="ctr" defTabSz="685800"/>
+            <a:r>
+              <a:rPr lang="fr-FR" sz="1350" dirty="0">
+                <a:ln w="0"/>
+                <a:solidFill>
+                  <a:schemeClr val="tx1"/>
+                </a:solidFill>
+                <a:effectLst>
+                  <a:outerShdw blurRad="38100" dist="19050" dir="2700000" algn="tl" rotWithShape="0">
+                    <a:schemeClr val="dk1">
+                      <a:alpha val="40000"/>
+                    </a:schemeClr>
+                  </a:outerShdw>
+                </a:effectLst>
+                <a:latin typeface="Calibri" panose="020F0502020204030204"/>
+              </a:rPr>
+              <a:t>24</a:t>
+            </a:r>
+          </a:p>
+        </p:txBody>
+      </p:sp>
+      <p:sp>
+        <p:nvSpPr>
+          <p:cNvPr id="11" name="Rectangle 10">
+            <a:extLst>
+              <a:ext uri="{FF2B5EF4-FFF2-40B4-BE49-F238E27FC236}">
+                <a16:creationId xmlns:a16="http://schemas.microsoft.com/office/drawing/2014/main" id="{DDE5C8C4-C0CA-4FD5-9CCB-310703A08BBD}"/>
+              </a:ext>
+            </a:extLst>
+          </p:cNvPr>
+          <p:cNvSpPr/>
+          <p:nvPr/>
+        </p:nvSpPr>
+        <p:spPr>
+          <a:xfrm>
+            <a:off x="4367267" y="3140968"/>
+            <a:ext cx="423569" cy="396000"/>
+          </a:xfrm>
+          <a:prstGeom prst="rect">
+            <a:avLst/>
+          </a:prstGeom>
+          <a:noFill/>
+          <a:ln w="9525"/>
+        </p:spPr>
+        <p:style>
+          <a:lnRef idx="2">
+            <a:schemeClr val="accent1">
+              <a:shade val="50000"/>
+            </a:schemeClr>
+          </a:lnRef>
+          <a:fillRef idx="1">
+            <a:schemeClr val="accent1"/>
+          </a:fillRef>
+          <a:effectRef idx="0">
+            <a:schemeClr val="accent1"/>
+          </a:effectRef>
+          <a:fontRef idx="minor">
+            <a:schemeClr val="lt1"/>
+          </a:fontRef>
+        </p:style>
+        <p:txBody>
+          <a:bodyPr rot="0" spcFirstLastPara="0" vertOverflow="overflow" horzOverflow="overflow" vert="horz" wrap="square" lIns="68580" tIns="34290" rIns="68580" bIns="34290" numCol="1" spcCol="0" rtlCol="0" fromWordArt="0" anchor="ctr" anchorCtr="0" forceAA="0" compatLnSpc="1">
+            <a:prstTxWarp prst="textNoShape">
+              <a:avLst/>
+            </a:prstTxWarp>
+            <a:noAutofit/>
+          </a:bodyPr>
+          <a:lstStyle/>
+          <a:p>
+            <a:pPr algn="ctr" defTabSz="685800"/>
+            <a:r>
+              <a:rPr lang="fr-FR" sz="1350" dirty="0">
+                <a:ln w="0"/>
+                <a:solidFill>
+                  <a:schemeClr val="tx1"/>
+                </a:solidFill>
+                <a:effectLst>
+                  <a:outerShdw blurRad="38100" dist="19050" dir="2700000" algn="tl" rotWithShape="0">
+                    <a:schemeClr val="dk1">
+                      <a:alpha val="40000"/>
+                    </a:schemeClr>
+                  </a:outerShdw>
+                </a:effectLst>
+                <a:latin typeface="Calibri" panose="020F0502020204030204"/>
+              </a:rPr>
+              <a:t>25</a:t>
+            </a:r>
+          </a:p>
+        </p:txBody>
+      </p:sp>
+      <p:sp>
+        <p:nvSpPr>
+          <p:cNvPr id="12" name="Rectangle 11">
+            <a:extLst>
+              <a:ext uri="{FF2B5EF4-FFF2-40B4-BE49-F238E27FC236}">
+                <a16:creationId xmlns:a16="http://schemas.microsoft.com/office/drawing/2014/main" id="{14921013-DADD-4335-80E0-5BEBC11C2462}"/>
+              </a:ext>
+            </a:extLst>
+          </p:cNvPr>
+          <p:cNvSpPr/>
+          <p:nvPr/>
+        </p:nvSpPr>
+        <p:spPr>
+          <a:xfrm>
+            <a:off x="4792726" y="3140968"/>
+            <a:ext cx="423569" cy="396000"/>
+          </a:xfrm>
+          <a:prstGeom prst="rect">
+            <a:avLst/>
+          </a:prstGeom>
+          <a:noFill/>
+          <a:ln w="9525"/>
+        </p:spPr>
+        <p:style>
+          <a:lnRef idx="2">
+            <a:schemeClr val="accent1">
+              <a:shade val="50000"/>
+            </a:schemeClr>
+          </a:lnRef>
+          <a:fillRef idx="1">
+            <a:schemeClr val="accent1"/>
+          </a:fillRef>
+          <a:effectRef idx="0">
+            <a:schemeClr val="accent1"/>
+          </a:effectRef>
+          <a:fontRef idx="minor">
+            <a:schemeClr val="lt1"/>
+          </a:fontRef>
+        </p:style>
+        <p:txBody>
+          <a:bodyPr rot="0" spcFirstLastPara="0" vertOverflow="overflow" horzOverflow="overflow" vert="horz" wrap="square" lIns="68580" tIns="34290" rIns="68580" bIns="34290" numCol="1" spcCol="0" rtlCol="0" fromWordArt="0" anchor="ctr" anchorCtr="0" forceAA="0" compatLnSpc="1">
+            <a:prstTxWarp prst="textNoShape">
+              <a:avLst/>
+            </a:prstTxWarp>
+            <a:noAutofit/>
+          </a:bodyPr>
+          <a:lstStyle/>
+          <a:p>
+            <a:pPr algn="ctr" defTabSz="685800"/>
+            <a:r>
+              <a:rPr lang="fr-FR" sz="1350" dirty="0">
+                <a:ln w="0"/>
+                <a:solidFill>
+                  <a:schemeClr val="tx1"/>
+                </a:solidFill>
+                <a:effectLst>
+                  <a:outerShdw blurRad="38100" dist="19050" dir="2700000" algn="tl" rotWithShape="0">
+                    <a:schemeClr val="dk1">
+                      <a:alpha val="40000"/>
+                    </a:schemeClr>
+                  </a:outerShdw>
+                </a:effectLst>
+                <a:latin typeface="Calibri" panose="020F0502020204030204"/>
+              </a:rPr>
+              <a:t>26</a:t>
+            </a:r>
+          </a:p>
+        </p:txBody>
+      </p:sp>
+      <p:sp>
+        <p:nvSpPr>
+          <p:cNvPr id="13" name="Rectangle 12">
+            <a:extLst>
+              <a:ext uri="{FF2B5EF4-FFF2-40B4-BE49-F238E27FC236}">
+                <a16:creationId xmlns:a16="http://schemas.microsoft.com/office/drawing/2014/main" id="{16F6895B-92A2-4981-91E9-C6C8341D6B91}"/>
+              </a:ext>
+            </a:extLst>
+          </p:cNvPr>
+          <p:cNvSpPr/>
+          <p:nvPr/>
+        </p:nvSpPr>
+        <p:spPr>
+          <a:xfrm>
+            <a:off x="5218185" y="3140968"/>
+            <a:ext cx="423569" cy="396000"/>
+          </a:xfrm>
+          <a:prstGeom prst="rect">
+            <a:avLst/>
+          </a:prstGeom>
+          <a:noFill/>
+          <a:ln w="9525"/>
+        </p:spPr>
+        <p:style>
+          <a:lnRef idx="2">
+            <a:schemeClr val="accent1">
+              <a:shade val="50000"/>
+            </a:schemeClr>
+          </a:lnRef>
+          <a:fillRef idx="1">
+            <a:schemeClr val="accent1"/>
+          </a:fillRef>
+          <a:effectRef idx="0">
+            <a:schemeClr val="accent1"/>
+          </a:effectRef>
+          <a:fontRef idx="minor">
+            <a:schemeClr val="lt1"/>
+          </a:fontRef>
+        </p:style>
+        <p:txBody>
+          <a:bodyPr rot="0" spcFirstLastPara="0" vertOverflow="overflow" horzOverflow="overflow" vert="horz" wrap="square" lIns="68580" tIns="34290" rIns="68580" bIns="34290" numCol="1" spcCol="0" rtlCol="0" fromWordArt="0" anchor="ctr" anchorCtr="0" forceAA="0" compatLnSpc="1">
+            <a:prstTxWarp prst="textNoShape">
+              <a:avLst/>
+            </a:prstTxWarp>
+            <a:noAutofit/>
+          </a:bodyPr>
+          <a:lstStyle/>
+          <a:p>
+            <a:pPr algn="ctr" defTabSz="685800"/>
+            <a:r>
+              <a:rPr lang="fr-FR" sz="1350" dirty="0">
+                <a:ln w="0"/>
+                <a:solidFill>
+                  <a:schemeClr val="tx1"/>
+                </a:solidFill>
+                <a:effectLst>
+                  <a:outerShdw blurRad="38100" dist="19050" dir="2700000" algn="tl" rotWithShape="0">
+                    <a:schemeClr val="dk1">
+                      <a:alpha val="40000"/>
+                    </a:schemeClr>
+                  </a:outerShdw>
+                </a:effectLst>
+                <a:latin typeface="Calibri" panose="020F0502020204030204"/>
+              </a:rPr>
+              <a:t>27</a:t>
+            </a:r>
+          </a:p>
+        </p:txBody>
+      </p:sp>
+      <p:sp>
+        <p:nvSpPr>
+          <p:cNvPr id="14" name="Rectangle 13">
+            <a:extLst>
+              <a:ext uri="{FF2B5EF4-FFF2-40B4-BE49-F238E27FC236}">
+                <a16:creationId xmlns:a16="http://schemas.microsoft.com/office/drawing/2014/main" id="{61342BAE-F3CF-4C02-8E6D-9A3981E56E44}"/>
+              </a:ext>
+            </a:extLst>
+          </p:cNvPr>
+          <p:cNvSpPr/>
+          <p:nvPr/>
+        </p:nvSpPr>
+        <p:spPr>
+          <a:xfrm>
+            <a:off x="5643644" y="3140968"/>
+            <a:ext cx="423569" cy="396000"/>
+          </a:xfrm>
+          <a:prstGeom prst="rect">
+            <a:avLst/>
+          </a:prstGeom>
+          <a:noFill/>
+          <a:ln w="9525"/>
+        </p:spPr>
+        <p:style>
+          <a:lnRef idx="2">
+            <a:schemeClr val="accent1">
+              <a:shade val="50000"/>
+            </a:schemeClr>
+          </a:lnRef>
+          <a:fillRef idx="1">
+            <a:schemeClr val="accent1"/>
+          </a:fillRef>
+          <a:effectRef idx="0">
+            <a:schemeClr val="accent1"/>
+          </a:effectRef>
+          <a:fontRef idx="minor">
+            <a:schemeClr val="lt1"/>
+          </a:fontRef>
+        </p:style>
+        <p:txBody>
+          <a:bodyPr rot="0" spcFirstLastPara="0" vertOverflow="overflow" horzOverflow="overflow" vert="horz" wrap="square" lIns="68580" tIns="34290" rIns="68580" bIns="34290" numCol="1" spcCol="0" rtlCol="0" fromWordArt="0" anchor="ctr" anchorCtr="0" forceAA="0" compatLnSpc="1">
+            <a:prstTxWarp prst="textNoShape">
+              <a:avLst/>
+            </a:prstTxWarp>
+            <a:noAutofit/>
+          </a:bodyPr>
+          <a:lstStyle/>
+          <a:p>
+            <a:pPr algn="ctr" defTabSz="685800"/>
+            <a:r>
+              <a:rPr lang="fr-FR" sz="1350" dirty="0">
+                <a:ln w="0"/>
+                <a:solidFill>
+                  <a:schemeClr val="tx1"/>
+                </a:solidFill>
+                <a:effectLst>
+                  <a:outerShdw blurRad="38100" dist="19050" dir="2700000" algn="tl" rotWithShape="0">
+                    <a:schemeClr val="dk1">
+                      <a:alpha val="40000"/>
+                    </a:schemeClr>
+                  </a:outerShdw>
+                </a:effectLst>
+                <a:latin typeface="Calibri" panose="020F0502020204030204"/>
+              </a:rPr>
+              <a:t>28</a:t>
+            </a:r>
+          </a:p>
+        </p:txBody>
+      </p:sp>
+      <p:sp>
+        <p:nvSpPr>
+          <p:cNvPr id="15" name="Rectangle 14">
+            <a:extLst>
+              <a:ext uri="{FF2B5EF4-FFF2-40B4-BE49-F238E27FC236}">
+                <a16:creationId xmlns:a16="http://schemas.microsoft.com/office/drawing/2014/main" id="{DE09D0A8-7AF8-4AAE-9D39-57739BD45F3F}"/>
+              </a:ext>
+            </a:extLst>
+          </p:cNvPr>
+          <p:cNvSpPr/>
+          <p:nvPr/>
+        </p:nvSpPr>
+        <p:spPr>
+          <a:xfrm>
+            <a:off x="6069103" y="3140968"/>
+            <a:ext cx="423569" cy="396000"/>
+          </a:xfrm>
+          <a:prstGeom prst="rect">
+            <a:avLst/>
+          </a:prstGeom>
+          <a:noFill/>
+          <a:ln w="9525"/>
+        </p:spPr>
+        <p:style>
+          <a:lnRef idx="2">
+            <a:schemeClr val="accent1">
+              <a:shade val="50000"/>
+            </a:schemeClr>
+          </a:lnRef>
+          <a:fillRef idx="1">
+            <a:schemeClr val="accent1"/>
+          </a:fillRef>
+          <a:effectRef idx="0">
+            <a:schemeClr val="accent1"/>
+          </a:effectRef>
+          <a:fontRef idx="minor">
+            <a:schemeClr val="lt1"/>
+          </a:fontRef>
+        </p:style>
+        <p:txBody>
+          <a:bodyPr rot="0" spcFirstLastPara="0" vertOverflow="overflow" horzOverflow="overflow" vert="horz" wrap="square" lIns="68580" tIns="34290" rIns="68580" bIns="34290" numCol="1" spcCol="0" rtlCol="0" fromWordArt="0" anchor="ctr" anchorCtr="0" forceAA="0" compatLnSpc="1">
+            <a:prstTxWarp prst="textNoShape">
+              <a:avLst/>
+            </a:prstTxWarp>
+            <a:noAutofit/>
+          </a:bodyPr>
+          <a:lstStyle/>
+          <a:p>
+            <a:pPr algn="ctr" defTabSz="685800"/>
+            <a:r>
+              <a:rPr lang="fr-FR" sz="1350" dirty="0">
+                <a:ln w="0"/>
+                <a:solidFill>
+                  <a:schemeClr val="tx1"/>
+                </a:solidFill>
+                <a:effectLst>
+                  <a:outerShdw blurRad="38100" dist="19050" dir="2700000" algn="tl" rotWithShape="0">
+                    <a:schemeClr val="dk1">
+                      <a:alpha val="40000"/>
+                    </a:schemeClr>
+                  </a:outerShdw>
+                </a:effectLst>
+                <a:latin typeface="Calibri" panose="020F0502020204030204"/>
+              </a:rPr>
+              <a:t>29</a:t>
+            </a:r>
+          </a:p>
+        </p:txBody>
+      </p:sp>
+      <p:sp>
+        <p:nvSpPr>
+          <p:cNvPr id="16" name="Rectangle 15">
+            <a:extLst>
+              <a:ext uri="{FF2B5EF4-FFF2-40B4-BE49-F238E27FC236}">
+                <a16:creationId xmlns:a16="http://schemas.microsoft.com/office/drawing/2014/main" id="{170A2E4D-AC5C-4E21-90B1-884EBD2FD0BA}"/>
+              </a:ext>
+            </a:extLst>
+          </p:cNvPr>
+          <p:cNvSpPr/>
+          <p:nvPr/>
+        </p:nvSpPr>
+        <p:spPr>
+          <a:xfrm>
+            <a:off x="6494567" y="3140968"/>
+            <a:ext cx="423569" cy="396000"/>
+          </a:xfrm>
+          <a:prstGeom prst="rect">
+            <a:avLst/>
+          </a:prstGeom>
+          <a:noFill/>
+          <a:ln w="9525"/>
+        </p:spPr>
+        <p:style>
+          <a:lnRef idx="2">
+            <a:schemeClr val="accent1">
+              <a:shade val="50000"/>
+            </a:schemeClr>
+          </a:lnRef>
+          <a:fillRef idx="1">
+            <a:schemeClr val="accent1"/>
+          </a:fillRef>
+          <a:effectRef idx="0">
+            <a:schemeClr val="accent1"/>
+          </a:effectRef>
+          <a:fontRef idx="minor">
+            <a:schemeClr val="lt1"/>
+          </a:fontRef>
+        </p:style>
+        <p:txBody>
+          <a:bodyPr rot="0" spcFirstLastPara="0" vertOverflow="overflow" horzOverflow="overflow" vert="horz" wrap="square" lIns="68580" tIns="34290" rIns="68580" bIns="34290" numCol="1" spcCol="0" rtlCol="0" fromWordArt="0" anchor="ctr" anchorCtr="0" forceAA="0" compatLnSpc="1">
+            <a:prstTxWarp prst="textNoShape">
+              <a:avLst/>
+            </a:prstTxWarp>
+            <a:noAutofit/>
+          </a:bodyPr>
+          <a:lstStyle/>
+          <a:p>
+            <a:pPr algn="ctr" defTabSz="685800"/>
+            <a:r>
+              <a:rPr lang="fr-FR" sz="1350" dirty="0">
+                <a:ln w="0"/>
+                <a:solidFill>
+                  <a:schemeClr val="tx1"/>
+                </a:solidFill>
+                <a:effectLst>
+                  <a:outerShdw blurRad="38100" dist="19050" dir="2700000" algn="tl" rotWithShape="0">
+                    <a:schemeClr val="dk1">
+                      <a:alpha val="40000"/>
+                    </a:schemeClr>
+                  </a:outerShdw>
+                </a:effectLst>
+                <a:latin typeface="Calibri" panose="020F0502020204030204"/>
+              </a:rPr>
+              <a:t>30</a:t>
+            </a:r>
+          </a:p>
+        </p:txBody>
+      </p:sp>
+      <p:sp>
+        <p:nvSpPr>
+          <p:cNvPr id="43" name="Rectangle 42">
+            <a:extLst>
+              <a:ext uri="{FF2B5EF4-FFF2-40B4-BE49-F238E27FC236}">
+                <a16:creationId xmlns:a16="http://schemas.microsoft.com/office/drawing/2014/main" id="{413A49C4-2EB0-4B9D-BA5C-D62F310EEB8B}"/>
+              </a:ext>
+            </a:extLst>
+          </p:cNvPr>
+          <p:cNvSpPr/>
+          <p:nvPr/>
+        </p:nvSpPr>
+        <p:spPr>
+          <a:xfrm>
+            <a:off x="7028751" y="3153829"/>
+            <a:ext cx="423569" cy="396000"/>
+          </a:xfrm>
+          <a:prstGeom prst="rect">
+            <a:avLst/>
+          </a:prstGeom>
+          <a:noFill/>
+          <a:ln w="28575"/>
+        </p:spPr>
+        <p:style>
+          <a:lnRef idx="2">
+            <a:schemeClr val="accent1">
+              <a:shade val="50000"/>
+            </a:schemeClr>
+          </a:lnRef>
+          <a:fillRef idx="1">
+            <a:schemeClr val="accent1"/>
+          </a:fillRef>
+          <a:effectRef idx="0">
+            <a:schemeClr val="accent1"/>
+          </a:effectRef>
+          <a:fontRef idx="minor">
+            <a:schemeClr val="lt1"/>
+          </a:fontRef>
+        </p:style>
+        <p:txBody>
+          <a:bodyPr rot="0" spcFirstLastPara="0" vertOverflow="overflow" horzOverflow="overflow" vert="horz" wrap="square" lIns="68580" tIns="34290" rIns="68580" bIns="34290" numCol="1" spcCol="0" rtlCol="0" fromWordArt="0" anchor="ctr" anchorCtr="0" forceAA="0" compatLnSpc="1">
+            <a:prstTxWarp prst="textNoShape">
+              <a:avLst/>
+            </a:prstTxWarp>
+            <a:noAutofit/>
+          </a:bodyPr>
+          <a:lstStyle/>
+          <a:p>
+            <a:pPr algn="ctr" defTabSz="685800"/>
+            <a:r>
+              <a:rPr lang="fr-FR" sz="1200" dirty="0">
+                <a:ln w="0"/>
+                <a:solidFill>
+                  <a:schemeClr val="tx1"/>
+                </a:solidFill>
+                <a:effectLst>
+                  <a:outerShdw blurRad="38100" dist="19050" dir="2700000" algn="tl" rotWithShape="0">
+                    <a:schemeClr val="dk1">
+                      <a:alpha val="40000"/>
+                    </a:schemeClr>
+                  </a:outerShdw>
+                </a:effectLst>
+                <a:latin typeface="Calibri" panose="020F0502020204030204"/>
+              </a:rPr>
+              <a:t>land</a:t>
+            </a:r>
+          </a:p>
+        </p:txBody>
+      </p:sp>
+      <p:pic>
+        <p:nvPicPr>
+          <p:cNvPr id="44" name="Image 43">
+            <a:extLst>
+              <a:ext uri="{FF2B5EF4-FFF2-40B4-BE49-F238E27FC236}">
+                <a16:creationId xmlns:a16="http://schemas.microsoft.com/office/drawing/2014/main" id="{6AF52CA8-5FDC-4E5B-8187-611351F692C5}"/>
+              </a:ext>
+            </a:extLst>
+          </p:cNvPr>
+          <p:cNvPicPr>
+            <a:picLocks noChangeAspect="1"/>
+          </p:cNvPicPr>
+          <p:nvPr/>
+        </p:nvPicPr>
+        <p:blipFill>
+          <a:blip r:embed="rId2"/>
+          <a:stretch>
+            <a:fillRect/>
+          </a:stretch>
+        </p:blipFill>
+        <p:spPr>
+          <a:xfrm>
+            <a:off x="611560" y="4365104"/>
+            <a:ext cx="7584081" cy="847417"/>
+          </a:xfrm>
+          <a:prstGeom prst="rect">
+            <a:avLst/>
+          </a:prstGeom>
+        </p:spPr>
+      </p:pic>
+    </p:spTree>
+    <p:extLst>
+      <p:ext uri="{BB962C8B-B14F-4D97-AF65-F5344CB8AC3E}">
+        <p14:creationId xmlns:p14="http://schemas.microsoft.com/office/powerpoint/2010/main" val="99111470"/>
+      </p:ext>
+    </p:extLst>
+  </p:cSld>
+  <p:clrMapOvr>
+    <a:masterClrMapping/>
+  </p:clrMapOvr>
+</p:sld>
+</file>
+
+<file path=ppt/slides/slide3.xml><?xml version="1.0" encoding="utf-8"?>
+<p:sld xmlns:a="http://schemas.openxmlformats.org/drawingml/2006/main" xmlns:r="http://schemas.openxmlformats.org/officeDocument/2006/relationships" xmlns:p="http://schemas.openxmlformats.org/presentationml/2006/main">
+  <p:cSld>
+    <p:spTree>
+      <p:nvGrpSpPr>
+        <p:cNvPr id="1" name=""/>
+        <p:cNvGrpSpPr/>
+        <p:nvPr/>
+      </p:nvGrpSpPr>
+      <p:grpSpPr>
+        <a:xfrm>
+          <a:off x="0" y="0"/>
+          <a:ext cx="0" cy="0"/>
+          <a:chOff x="0" y="0"/>
+          <a:chExt cx="0" cy="0"/>
+        </a:xfrm>
+      </p:grpSpPr>
       <p:pic>
         <p:nvPicPr>
           <p:cNvPr id="2" name="Image 1"/>
@@ -3438,30 +5311,6 @@
           </a:p>
         </p:txBody>
       </p:sp>
-      <p:pic>
-        <p:nvPicPr>
-          <p:cNvPr id="34" name="Image 33"/>
-          <p:cNvPicPr>
-            <a:picLocks noChangeAspect="1"/>
-          </p:cNvPicPr>
-          <p:nvPr/>
-        </p:nvPicPr>
-        <p:blipFill>
-          <a:blip r:embed="rId4"/>
-          <a:stretch>
-            <a:fillRect/>
-          </a:stretch>
-        </p:blipFill>
-        <p:spPr>
-          <a:xfrm>
-            <a:off x="3195260" y="143807"/>
-            <a:ext cx="5346655" cy="871804"/>
-          </a:xfrm>
-          <a:prstGeom prst="rect">
-            <a:avLst/>
-          </a:prstGeom>
-        </p:spPr>
-      </p:pic>
       <p:sp>
         <p:nvSpPr>
           <p:cNvPr id="35" name="Rectangle 34"/>
@@ -3508,10 +5357,40 @@
           </a:p>
         </p:txBody>
       </p:sp>
+      <p:pic>
+        <p:nvPicPr>
+          <p:cNvPr id="7" name="Image 6">
+            <a:extLst>
+              <a:ext uri="{FF2B5EF4-FFF2-40B4-BE49-F238E27FC236}">
+                <a16:creationId xmlns:a16="http://schemas.microsoft.com/office/drawing/2014/main" id="{89300997-9F17-4992-BB0D-FDAFD1F1C6F3}"/>
+              </a:ext>
+            </a:extLst>
+          </p:cNvPr>
+          <p:cNvPicPr>
+            <a:picLocks noChangeAspect="1"/>
+          </p:cNvPicPr>
+          <p:nvPr/>
+        </p:nvPicPr>
+        <p:blipFill>
+          <a:blip r:embed="rId4"/>
+          <a:stretch>
+            <a:fillRect/>
+          </a:stretch>
+        </p:blipFill>
+        <p:spPr>
+          <a:xfrm>
+            <a:off x="2388519" y="89436"/>
+            <a:ext cx="5999905" cy="670407"/>
+          </a:xfrm>
+          <a:prstGeom prst="rect">
+            <a:avLst/>
+          </a:prstGeom>
+        </p:spPr>
+      </p:pic>
     </p:spTree>
     <p:extLst>
       <p:ext uri="{BB962C8B-B14F-4D97-AF65-F5344CB8AC3E}">
-        <p14:creationId xmlns:p14="http://schemas.microsoft.com/office/powerpoint/2010/main" val="765280666"/>
+        <p14:creationId xmlns:p14="http://schemas.microsoft.com/office/powerpoint/2010/main" val="3050280596"/>
       </p:ext>
     </p:extLst>
   </p:cSld>
@@ -3521,7 +5400,7 @@
 </p:sld>
 </file>
 
-<file path=ppt/slides/slide2.xml><?xml version="1.0" encoding="utf-8"?>
+<file path=ppt/slides/slide4.xml><?xml version="1.0" encoding="utf-8"?>
 <p:sld xmlns:a="http://schemas.openxmlformats.org/drawingml/2006/main" xmlns:r="http://schemas.openxmlformats.org/officeDocument/2006/relationships" xmlns:p="http://schemas.openxmlformats.org/presentationml/2006/main">
   <p:cSld>
     <p:spTree>
@@ -3538,23 +5417,68 @@
           <a:chExt cx="0" cy="0"/>
         </a:xfrm>
       </p:grpSpPr>
-      <p:sp>
-        <p:nvSpPr>
-          <p:cNvPr id="6" name="Rectangle 5"/>
+      <p:pic>
+        <p:nvPicPr>
+          <p:cNvPr id="2" name="Image 1"/>
+          <p:cNvPicPr>
+            <a:picLocks noChangeAspect="1"/>
+          </p:cNvPicPr>
+          <p:nvPr/>
+        </p:nvPicPr>
+        <p:blipFill>
+          <a:blip r:embed="rId2">
+            <a:clrChange>
+              <a:clrFrom>
+                <a:srgbClr val="000000">
+                  <a:alpha val="0"/>
+                </a:srgbClr>
+              </a:clrFrom>
+              <a:clrTo>
+                <a:srgbClr val="000000">
+                  <a:alpha val="0"/>
+                </a:srgbClr>
+              </a:clrTo>
+            </a:clrChange>
+            <a:extLst>
+              <a:ext uri="{28A0092B-C50C-407E-A947-70E740481C1C}">
+                <a14:useLocalDpi xmlns:a14="http://schemas.microsoft.com/office/drawing/2010/main" val="0"/>
+              </a:ext>
+            </a:extLst>
+          </a:blip>
+          <a:stretch>
+            <a:fillRect/>
+          </a:stretch>
+        </p:blipFill>
+        <p:spPr>
+          <a:xfrm>
+            <a:off x="0" y="120316"/>
+            <a:ext cx="9144000" cy="6617368"/>
+          </a:xfrm>
+          <a:prstGeom prst="rect">
+            <a:avLst/>
+          </a:prstGeom>
+        </p:spPr>
+      </p:pic>
+      <p:sp>
+        <p:nvSpPr>
+          <p:cNvPr id="4" name="Rectangle 3"/>
           <p:cNvSpPr/>
           <p:nvPr/>
         </p:nvSpPr>
         <p:spPr>
           <a:xfrm>
-            <a:off x="3187915" y="1116746"/>
-            <a:ext cx="288032" cy="288032"/>
+            <a:off x="202958" y="126177"/>
+            <a:ext cx="716206" cy="773936"/>
           </a:xfrm>
           <a:prstGeom prst="rect">
             <a:avLst/>
           </a:prstGeom>
           <a:solidFill>
-            <a:srgbClr val="000AF3"/>
+            <a:srgbClr val="CCCCCC"/>
           </a:solidFill>
+          <a:ln>
+            <a:noFill/>
+          </a:ln>
         </p:spPr>
         <p:style>
           <a:lnRef idx="2">
@@ -3581,23 +5505,50 @@
           </a:p>
         </p:txBody>
       </p:sp>
-      <p:sp>
-        <p:nvSpPr>
-          <p:cNvPr id="7" name="Rectangle 6"/>
+      <p:pic>
+        <p:nvPicPr>
+          <p:cNvPr id="3" name="Image 2"/>
+          <p:cNvPicPr>
+            <a:picLocks noChangeAspect="1"/>
+          </p:cNvPicPr>
+          <p:nvPr/>
+        </p:nvPicPr>
+        <p:blipFill>
+          <a:blip r:embed="rId3"/>
+          <a:stretch>
+            <a:fillRect/>
+          </a:stretch>
+        </p:blipFill>
+        <p:spPr>
+          <a:xfrm>
+            <a:off x="166956" y="110791"/>
+            <a:ext cx="788210" cy="860412"/>
+          </a:xfrm>
+          <a:prstGeom prst="rect">
+            <a:avLst/>
+          </a:prstGeom>
+        </p:spPr>
+      </p:pic>
+      <p:sp>
+        <p:nvSpPr>
+          <p:cNvPr id="6" name="Rectangle 5"/>
           <p:cNvSpPr/>
           <p:nvPr/>
         </p:nvSpPr>
         <p:spPr>
           <a:xfrm>
-            <a:off x="3578670" y="1116746"/>
-            <a:ext cx="288032" cy="288032"/>
+            <a:off x="5510485" y="138113"/>
+            <a:ext cx="716206" cy="722981"/>
           </a:xfrm>
           <a:prstGeom prst="rect">
             <a:avLst/>
           </a:prstGeom>
           <a:solidFill>
-            <a:srgbClr val="00AF51"/>
+            <a:srgbClr val="CCCCCC"/>
           </a:solidFill>
+          <a:ln>
+            <a:noFill/>
+          </a:ln>
         </p:spPr>
         <p:style>
           <a:lnRef idx="2">
@@ -3624,23 +5575,50 @@
           </a:p>
         </p:txBody>
       </p:sp>
-      <p:sp>
-        <p:nvSpPr>
-          <p:cNvPr id="8" name="Rectangle 7"/>
+      <p:pic>
+        <p:nvPicPr>
+          <p:cNvPr id="34" name="Image 33"/>
+          <p:cNvPicPr>
+            <a:picLocks noChangeAspect="1"/>
+          </p:cNvPicPr>
+          <p:nvPr/>
+        </p:nvPicPr>
+        <p:blipFill>
+          <a:blip r:embed="rId4"/>
+          <a:stretch>
+            <a:fillRect/>
+          </a:stretch>
+        </p:blipFill>
+        <p:spPr>
+          <a:xfrm>
+            <a:off x="3195260" y="143807"/>
+            <a:ext cx="5346655" cy="871804"/>
+          </a:xfrm>
+          <a:prstGeom prst="rect">
+            <a:avLst/>
+          </a:prstGeom>
+        </p:spPr>
+      </p:pic>
+      <p:sp>
+        <p:nvSpPr>
+          <p:cNvPr id="35" name="Rectangle 34"/>
           <p:cNvSpPr/>
           <p:nvPr/>
         </p:nvSpPr>
         <p:spPr>
           <a:xfrm>
-            <a:off x="3969425" y="1116746"/>
-            <a:ext cx="288032" cy="288032"/>
+            <a:off x="6948263" y="5949281"/>
+            <a:ext cx="1593651" cy="360040"/>
           </a:xfrm>
           <a:prstGeom prst="rect">
             <a:avLst/>
           </a:prstGeom>
           <a:solidFill>
-            <a:srgbClr val="3EFF00"/>
+            <a:srgbClr val="CCCCCC"/>
           </a:solidFill>
+          <a:ln>
+            <a:noFill/>
+          </a:ln>
         </p:spPr>
         <p:style>
           <a:lnRef idx="2">
@@ -3667,22 +5645,52 @@
           </a:p>
         </p:txBody>
       </p:sp>
-      <p:sp>
-        <p:nvSpPr>
-          <p:cNvPr id="9" name="Rectangle 8"/>
+    </p:spTree>
+    <p:extLst>
+      <p:ext uri="{BB962C8B-B14F-4D97-AF65-F5344CB8AC3E}">
+        <p14:creationId xmlns:p14="http://schemas.microsoft.com/office/powerpoint/2010/main" val="765280666"/>
+      </p:ext>
+    </p:extLst>
+  </p:cSld>
+  <p:clrMapOvr>
+    <a:masterClrMapping/>
+  </p:clrMapOvr>
+</p:sld>
+</file>
+
+<file path=ppt/slides/slide5.xml><?xml version="1.0" encoding="utf-8"?>
+<p:sld xmlns:a="http://schemas.openxmlformats.org/drawingml/2006/main" xmlns:r="http://schemas.openxmlformats.org/officeDocument/2006/relationships" xmlns:p="http://schemas.openxmlformats.org/presentationml/2006/main">
+  <p:cSld>
+    <p:spTree>
+      <p:nvGrpSpPr>
+        <p:cNvPr id="1" name=""/>
+        <p:cNvGrpSpPr/>
+        <p:nvPr/>
+      </p:nvGrpSpPr>
+      <p:grpSpPr>
+        <a:xfrm>
+          <a:off x="0" y="0"/>
+          <a:ext cx="0" cy="0"/>
+          <a:chOff x="0" y="0"/>
+          <a:chExt cx="0" cy="0"/>
+        </a:xfrm>
+      </p:grpSpPr>
+      <p:sp>
+        <p:nvSpPr>
+          <p:cNvPr id="6" name="Rectangle 5"/>
           <p:cNvSpPr/>
           <p:nvPr/>
         </p:nvSpPr>
         <p:spPr>
           <a:xfrm>
-            <a:off x="4360180" y="1116746"/>
+            <a:off x="3187915" y="1116746"/>
             <a:ext cx="288032" cy="288032"/>
           </a:xfrm>
           <a:prstGeom prst="rect">
             <a:avLst/>
           </a:prstGeom>
           <a:solidFill>
-            <a:srgbClr val="FFFB01"/>
+            <a:srgbClr val="000AF3"/>
           </a:solidFill>
         </p:spPr>
         <p:style>
@@ -3712,20 +5720,20 @@
       </p:sp>
       <p:sp>
         <p:nvSpPr>
-          <p:cNvPr id="10" name="Rectangle 9"/>
+          <p:cNvPr id="7" name="Rectangle 6"/>
           <p:cNvSpPr/>
           <p:nvPr/>
         </p:nvSpPr>
         <p:spPr>
           <a:xfrm>
-            <a:off x="4750935" y="1116746"/>
+            <a:off x="3578670" y="1116746"/>
             <a:ext cx="288032" cy="288032"/>
           </a:xfrm>
           <a:prstGeom prst="rect">
             <a:avLst/>
           </a:prstGeom>
           <a:solidFill>
-            <a:srgbClr val="FFA800"/>
+            <a:srgbClr val="00AF51"/>
           </a:solidFill>
         </p:spPr>
         <p:style>
@@ -3755,20 +5763,20 @@
       </p:sp>
       <p:sp>
         <p:nvSpPr>
-          <p:cNvPr id="11" name="Rectangle 10"/>
+          <p:cNvPr id="8" name="Rectangle 7"/>
           <p:cNvSpPr/>
           <p:nvPr/>
         </p:nvSpPr>
         <p:spPr>
           <a:xfrm>
-            <a:off x="5141690" y="1116746"/>
+            <a:off x="3969425" y="1116746"/>
             <a:ext cx="288032" cy="288032"/>
           </a:xfrm>
           <a:prstGeom prst="rect">
             <a:avLst/>
           </a:prstGeom>
           <a:solidFill>
-            <a:srgbClr val="FF6D00"/>
+            <a:srgbClr val="3EFF00"/>
           </a:solidFill>
         </p:spPr>
         <p:style>
@@ -3798,20 +5806,20 @@
       </p:sp>
       <p:sp>
         <p:nvSpPr>
-          <p:cNvPr id="12" name="Rectangle 11"/>
+          <p:cNvPr id="9" name="Rectangle 8"/>
           <p:cNvSpPr/>
           <p:nvPr/>
         </p:nvSpPr>
         <p:spPr>
           <a:xfrm>
-            <a:off x="5532445" y="1116746"/>
+            <a:off x="4360180" y="1116746"/>
             <a:ext cx="288032" cy="288032"/>
           </a:xfrm>
           <a:prstGeom prst="rect">
             <a:avLst/>
           </a:prstGeom>
           <a:solidFill>
-            <a:srgbClr val="FE1100"/>
+            <a:srgbClr val="FFFB01"/>
           </a:solidFill>
         </p:spPr>
         <p:style>
@@ -3841,20 +5849,20 @@
       </p:sp>
       <p:sp>
         <p:nvSpPr>
-          <p:cNvPr id="13" name="Rectangle 12"/>
+          <p:cNvPr id="10" name="Rectangle 9"/>
           <p:cNvSpPr/>
           <p:nvPr/>
         </p:nvSpPr>
         <p:spPr>
           <a:xfrm>
-            <a:off x="5923197" y="1116746"/>
+            <a:off x="4750935" y="1116746"/>
             <a:ext cx="288032" cy="288032"/>
           </a:xfrm>
           <a:prstGeom prst="rect">
             <a:avLst/>
           </a:prstGeom>
           <a:solidFill>
-            <a:schemeClr val="bg1"/>
+            <a:srgbClr val="FFA800"/>
           </a:solidFill>
         </p:spPr>
         <p:style>
@@ -3884,6 +5892,135 @@
       </p:sp>
       <p:sp>
         <p:nvSpPr>
+          <p:cNvPr id="11" name="Rectangle 10"/>
+          <p:cNvSpPr/>
+          <p:nvPr/>
+        </p:nvSpPr>
+        <p:spPr>
+          <a:xfrm>
+            <a:off x="5141690" y="1116746"/>
+            <a:ext cx="288032" cy="288032"/>
+          </a:xfrm>
+          <a:prstGeom prst="rect">
+            <a:avLst/>
+          </a:prstGeom>
+          <a:solidFill>
+            <a:srgbClr val="FF6D00"/>
+          </a:solidFill>
+        </p:spPr>
+        <p:style>
+          <a:lnRef idx="2">
+            <a:schemeClr val="accent1">
+              <a:shade val="50000"/>
+            </a:schemeClr>
+          </a:lnRef>
+          <a:fillRef idx="1">
+            <a:schemeClr val="accent1"/>
+          </a:fillRef>
+          <a:effectRef idx="0">
+            <a:schemeClr val="accent1"/>
+          </a:effectRef>
+          <a:fontRef idx="minor">
+            <a:schemeClr val="lt1"/>
+          </a:fontRef>
+        </p:style>
+        <p:txBody>
+          <a:bodyPr rtlCol="0" anchor="ctr"/>
+          <a:lstStyle/>
+          <a:p>
+            <a:pPr algn="ctr"/>
+            <a:endParaRPr lang="fr-FR"/>
+          </a:p>
+        </p:txBody>
+      </p:sp>
+      <p:sp>
+        <p:nvSpPr>
+          <p:cNvPr id="12" name="Rectangle 11"/>
+          <p:cNvSpPr/>
+          <p:nvPr/>
+        </p:nvSpPr>
+        <p:spPr>
+          <a:xfrm>
+            <a:off x="5532445" y="1116746"/>
+            <a:ext cx="288032" cy="288032"/>
+          </a:xfrm>
+          <a:prstGeom prst="rect">
+            <a:avLst/>
+          </a:prstGeom>
+          <a:solidFill>
+            <a:srgbClr val="FE1100"/>
+          </a:solidFill>
+        </p:spPr>
+        <p:style>
+          <a:lnRef idx="2">
+            <a:schemeClr val="accent1">
+              <a:shade val="50000"/>
+            </a:schemeClr>
+          </a:lnRef>
+          <a:fillRef idx="1">
+            <a:schemeClr val="accent1"/>
+          </a:fillRef>
+          <a:effectRef idx="0">
+            <a:schemeClr val="accent1"/>
+          </a:effectRef>
+          <a:fontRef idx="minor">
+            <a:schemeClr val="lt1"/>
+          </a:fontRef>
+        </p:style>
+        <p:txBody>
+          <a:bodyPr rtlCol="0" anchor="ctr"/>
+          <a:lstStyle/>
+          <a:p>
+            <a:pPr algn="ctr"/>
+            <a:endParaRPr lang="fr-FR"/>
+          </a:p>
+        </p:txBody>
+      </p:sp>
+      <p:sp>
+        <p:nvSpPr>
+          <p:cNvPr id="13" name="Rectangle 12"/>
+          <p:cNvSpPr/>
+          <p:nvPr/>
+        </p:nvSpPr>
+        <p:spPr>
+          <a:xfrm>
+            <a:off x="5923197" y="1116746"/>
+            <a:ext cx="288032" cy="288032"/>
+          </a:xfrm>
+          <a:prstGeom prst="rect">
+            <a:avLst/>
+          </a:prstGeom>
+          <a:solidFill>
+            <a:schemeClr val="bg1"/>
+          </a:solidFill>
+        </p:spPr>
+        <p:style>
+          <a:lnRef idx="2">
+            <a:schemeClr val="accent1">
+              <a:shade val="50000"/>
+            </a:schemeClr>
+          </a:lnRef>
+          <a:fillRef idx="1">
+            <a:schemeClr val="accent1"/>
+          </a:fillRef>
+          <a:effectRef idx="0">
+            <a:schemeClr val="accent1"/>
+          </a:effectRef>
+          <a:fontRef idx="minor">
+            <a:schemeClr val="lt1"/>
+          </a:fontRef>
+        </p:style>
+        <p:txBody>
+          <a:bodyPr rtlCol="0" anchor="ctr"/>
+          <a:lstStyle/>
+          <a:p>
+            <a:pPr algn="ctr"/>
+            <a:endParaRPr lang="fr-FR"/>
+          </a:p>
+        </p:txBody>
+      </p:sp>
+      <p:sp>
+        <p:nvSpPr>
           <p:cNvPr id="14" name="Rectangle 13"/>
           <p:cNvSpPr/>
           <p:nvPr/>
@@ -4479,26 +6616,23 @@
           <a:lstStyle/>
           <a:p>
             <a:r>
-              <a:rPr lang="fr-FR" sz="2400" b="1" dirty="0" err="1" smtClean="0">
+              <a:rPr lang="fr-FR" sz="2400" b="1" dirty="0" err="1">
                 <a:latin typeface="Abadi MT Condensed Light" panose="020B0306030101010103" pitchFamily="34" charset="0"/>
               </a:rPr>
               <a:t>Micronekton</a:t>
             </a:r>
             <a:r>
-              <a:rPr lang="fr-FR" sz="2400" b="1" dirty="0" smtClean="0">
+              <a:rPr lang="fr-FR" sz="2400" b="1" dirty="0">
                 <a:latin typeface="Abadi MT Condensed Light" panose="020B0306030101010103" pitchFamily="34" charset="0"/>
               </a:rPr>
               <a:t> g/m</a:t>
             </a:r>
             <a:r>
-              <a:rPr lang="fr-FR" sz="2400" b="1" baseline="30000" dirty="0" smtClean="0">
+              <a:rPr lang="fr-FR" sz="2400" b="1" baseline="30000" dirty="0">
                 <a:latin typeface="Abadi MT Condensed Light" panose="020B0306030101010103" pitchFamily="34" charset="0"/>
               </a:rPr>
               <a:t>2</a:t>
             </a:r>
-            <a:endParaRPr lang="fr-FR" sz="2400" b="1" baseline="30000" dirty="0">
-              <a:latin typeface="Abadi MT Condensed Light" panose="020B0306030101010103" pitchFamily="34" charset="0"/>
-            </a:endParaRPr>
           </a:p>
         </p:txBody>
       </p:sp>
@@ -4525,7 +6659,7 @@
           <a:lstStyle/>
           <a:p>
             <a:r>
-              <a:rPr lang="fr-FR" dirty="0" smtClean="0"/>
+              <a:rPr lang="fr-FR" dirty="0"/>
               <a:t>.2</a:t>
             </a:r>
           </a:p>
@@ -4554,7 +6688,7 @@
           <a:lstStyle/>
           <a:p>
             <a:r>
-              <a:rPr lang="fr-FR" dirty="0" smtClean="0"/>
+              <a:rPr lang="fr-FR" dirty="0"/>
               <a:t>.5</a:t>
             </a:r>
           </a:p>
@@ -4583,7 +6717,7 @@
           <a:lstStyle/>
           <a:p>
             <a:r>
-              <a:rPr lang="fr-FR" dirty="0" smtClean="0"/>
+              <a:rPr lang="fr-FR" dirty="0"/>
               <a:t>1.</a:t>
             </a:r>
           </a:p>
@@ -4612,7 +6746,7 @@
           <a:lstStyle/>
           <a:p>
             <a:r>
-              <a:rPr lang="fr-FR" dirty="0" smtClean="0"/>
+              <a:rPr lang="fr-FR" dirty="0"/>
               <a:t>1.5</a:t>
             </a:r>
           </a:p>
@@ -4641,7 +6775,7 @@
           <a:lstStyle/>
           <a:p>
             <a:r>
-              <a:rPr lang="fr-FR" dirty="0" smtClean="0"/>
+              <a:rPr lang="fr-FR" dirty="0"/>
               <a:t>2.</a:t>
             </a:r>
           </a:p>
@@ -4670,7 +6804,7 @@
           <a:lstStyle/>
           <a:p>
             <a:r>
-              <a:rPr lang="fr-FR" dirty="0" smtClean="0"/>
+              <a:rPr lang="fr-FR" dirty="0"/>
               <a:t>&gt;3</a:t>
             </a:r>
           </a:p>
@@ -4699,7 +6833,7 @@
           <a:lstStyle/>
           <a:p>
             <a:r>
-              <a:rPr lang="fr-FR" dirty="0" smtClean="0"/>
+              <a:rPr lang="fr-FR" dirty="0"/>
               <a:t>&lt;.2</a:t>
             </a:r>
           </a:p>
@@ -4728,7 +6862,7 @@
           <a:lstStyle/>
           <a:p>
             <a:r>
-              <a:rPr lang="fr-FR" sz="1400" dirty="0" smtClean="0"/>
+              <a:rPr lang="fr-FR" sz="1400" dirty="0"/>
               <a:t>land</a:t>
             </a:r>
           </a:p>

</xml_diff>